<commit_message>
Gap 1: Atlas can dial and control the call
Two new Atlas tools using the navigate_to side-channel pattern:
- start_call({leadId?|phone?}) — resolves the lead's phone + name (or
  normalizes a raw number) and returns a {dial} payload; the SSE bridge
  emits a 'dial' event. Assist mode renders a click-to-call DialCard;
  Auto Pilot dials immediately via CallContext.dialNumber (never while
  a call is already live).
- control_call({action: hangup|mute|unmute}) — verifies the agent has a
  live call (activeCalls registry), returns {callControl}; FE executes
  through a new pendingControl relay (CallContext -> CallRuntime ->
  Twilio handle), mirroring the pendingDial pattern. Executes in both
  modes — the explicit chat request is the consent.

System prompt gains a Call control section ("call John Smith" ->
search_leads -> start_call). Note: tool-list change invalidates the
Atlas prompt cache once on deploy (expected).

Co-Authored-By: Claude Fable 5 <noreply@anthropic.com>
</commit_message>
<xml_diff>
--- a/MedHub_POC.pptx
+++ b/MedHub_POC.pptx
@@ -15,9 +15,10 @@
     <p:sldId id="263" r:id="rId9"/>
     <p:sldId id="264" r:id="rId10"/>
     <p:sldId id="265" r:id="rId11"/>
+    <p:sldId id="266" r:id="rId12"/>
   </p:sldIdLst>
   <p:notesMasterIdLst>
-    <p:notesMasterId r:id="rId12"/>
+    <p:notesMasterId r:id="rId13"/>
   </p:notesMasterIdLst>
   <p:sldSz cx="12191695" cy="6858000"/>
   <p:notesSz cx="6858000" cy="12191695"/>
@@ -623,6 +624,94 @@
             <a:fld id="{F7021451-1387-4CA6-816F-3879F97B5CBC}" type="slidenum">
               <a:rPr lang="en-US"/>
               <a:t>10</a:t>
+            </a:fld>
+            <a:endParaRPr lang="en-US"/>
+          </a:p>
+        </p:txBody>
+      </p:sp>
+    </p:spTree>
+    <p:extLst>
+      <p:ext uri="{BB962C8B-B14F-4D97-AF65-F5344CB8AC3E}">
+        <p14:creationId xmlns:p14="http://schemas.microsoft.com/office/powerpoint/2010/main" val="1024086991"/>
+      </p:ext>
+    </p:extLst>
+  </p:cSld>
+  <p:clrMapOvr>
+    <a:masterClrMapping/>
+  </p:clrMapOvr>
+</p:notes>
+</file>
+
+<file path=ppt/notesSlides/notesSlide11.xml><?xml version="1.0" encoding="utf-8"?>
+<p:notes xmlns:a="http://schemas.openxmlformats.org/drawingml/2006/main" xmlns:r="http://schemas.openxmlformats.org/officeDocument/2006/relationships" xmlns:p="http://schemas.openxmlformats.org/presentationml/2006/main">
+  <p:cSld>
+    <p:spTree>
+      <p:nvGrpSpPr>
+        <p:cNvPr id="1" name=""/>
+        <p:cNvGrpSpPr/>
+        <p:nvPr/>
+      </p:nvGrpSpPr>
+      <p:grpSpPr>
+        <a:xfrm>
+          <a:off x="0" y="0"/>
+          <a:ext cx="0" cy="0"/>
+          <a:chOff x="0" y="0"/>
+          <a:chExt cx="0" cy="0"/>
+        </a:xfrm>
+      </p:grpSpPr>
+      <p:sp>
+        <p:nvSpPr>
+          <p:cNvPr id="2" name="Slide Image Placeholder 1"/>
+          <p:cNvSpPr>
+            <a:spLocks noGrp="1" noRot="1" noChangeAspect="1"/>
+          </p:cNvSpPr>
+          <p:nvPr>
+            <p:ph type="sldImg"/>
+          </p:nvPr>
+        </p:nvSpPr>
+        <p:spPr/>
+      </p:sp>
+      <p:sp>
+        <p:nvSpPr>
+          <p:cNvPr id="3" name="Notes Placeholder 2"/>
+          <p:cNvSpPr>
+            <a:spLocks noGrp="1"/>
+          </p:cNvSpPr>
+          <p:nvPr>
+            <p:ph type="body" idx="1"/>
+          </p:nvPr>
+        </p:nvSpPr>
+        <p:spPr/>
+        <p:txBody>
+          <a:bodyPr/>
+          <a:lstStyle/>
+          <a:p>
+            <a:r>
+              <a:rPr lang="en-US" dirty="0"/>
+              <a:t>The full deployment path. Clients — supervisor and agent browsers plus the prospect's phone — reach the platform through the Cloudflare edge; Twilio carries the calls and streams media over signed webhooks and WebSockets. Everything lands on a containerized, cloud-portable application server: an outbound-only tunnel connector (no inbound ports), a Caddy gateway, the Express API, the agentic AI layer, and the real-time analysis pipeline. Deepgram handles streaming STT and Claude models are reached via OpenRouter. On-host data &amp; vector stack: the Ollama embedder (nomic-embed-text, 768-d) feeds Qdrant — five collections (plans, benefits, drugs, formulary, FAQs) behind a hybrid BM25 + vector retriever with RRF fusion that powers plan search, comparison, and explain — and MongoDB persists app and reference data. Security posture along the bottom.</a:t>
+            </a:r>
+            <a:endParaRPr lang="en-US" dirty="0"/>
+          </a:p>
+        </p:txBody>
+      </p:sp>
+      <p:sp>
+        <p:nvSpPr>
+          <p:cNvPr id="4" name="Slide Number Placeholder 3"/>
+          <p:cNvSpPr>
+            <a:spLocks noGrp="1"/>
+          </p:cNvSpPr>
+          <p:nvPr>
+            <p:ph type="sldNum" sz="quarter" idx="10"/>
+          </p:nvPr>
+        </p:nvSpPr>
+        <p:spPr/>
+        <p:txBody>
+          <a:bodyPr/>
+          <a:lstStyle/>
+          <a:p>
+            <a:fld id="{F7021451-1387-4CA6-816F-3879F97B5CBC}" type="slidenum">
+              <a:rPr lang="en-US"/>
+              <a:t>11</a:t>
             </a:fld>
             <a:endParaRPr lang="en-US"/>
           </a:p>
@@ -3130,6 +3219,3776 @@
 </p:sld>
 </file>
 
+<file path=ppt/slides/slide11.xml><?xml version="1.0" encoding="utf-8"?>
+<p:sld xmlns:a="http://schemas.openxmlformats.org/drawingml/2006/main" xmlns:r="http://schemas.openxmlformats.org/officeDocument/2006/relationships" xmlns:p="http://schemas.openxmlformats.org/presentationml/2006/main">
+  <p:cSld name="Slide 11">
+    <p:bg>
+      <p:bgPr>
+        <a:solidFill>
+          <a:srgbClr val="FFFFFF"/>
+        </a:solidFill>
+      </p:bgPr>
+    </p:bg>
+    <p:spTree>
+      <p:nvGrpSpPr>
+        <p:cNvPr id="1" name=""/>
+        <p:cNvGrpSpPr/>
+        <p:nvPr/>
+      </p:nvGrpSpPr>
+      <p:grpSpPr>
+        <a:xfrm>
+          <a:off x="0" y="0"/>
+          <a:ext cx="0" cy="0"/>
+          <a:chOff x="0" y="0"/>
+          <a:chExt cx="0" cy="0"/>
+        </a:xfrm>
+      </p:grpSpPr>
+      <p:sp>
+        <p:nvSpPr>
+          <p:cNvPr id="2" name="Text 0"/>
+          <p:cNvSpPr/>
+          <p:nvPr/>
+        </p:nvSpPr>
+        <p:spPr>
+          <a:xfrm>
+            <a:off x="777240" y="384048"/>
+            <a:ext cx="2377440" cy="384048"/>
+          </a:xfrm>
+          <a:prstGeom prst="roundRect">
+            <a:avLst>
+              <a:gd name="adj" fmla="val 50000"/>
+            </a:avLst>
+          </a:prstGeom>
+          <a:solidFill>
+            <a:srgbClr val="222B36"/>
+          </a:solidFill>
+          <a:ln/>
+        </p:spPr>
+        <p:txBody>
+          <a:bodyPr wrap="square" rtlCol="0" anchor="ctr"/>
+          <a:lstStyle/>
+          <a:p>
+            <a:pPr algn="ctr" indent="0" marL="0">
+              <a:buNone/>
+            </a:pPr>
+            <a:r>
+              <a:rPr lang="en-US" sz="1150" b="1" spc="200" kern="0" dirty="0">
+                <a:solidFill>
+                  <a:srgbClr val="FFFFFF"/>
+                </a:solidFill>
+                <a:latin typeface="Calibri" pitchFamily="34" charset="0"/>
+                <a:ea typeface="Calibri" pitchFamily="34" charset="-122"/>
+                <a:cs typeface="Calibri" pitchFamily="34" charset="-120"/>
+              </a:rPr>
+              <a:t>INFRASTRUCTURE</a:t>
+            </a:r>
+            <a:endParaRPr lang="en-US" sz="1150" dirty="0"/>
+          </a:p>
+        </p:txBody>
+      </p:sp>
+      <p:sp>
+        <p:nvSpPr>
+          <p:cNvPr id="3" name="Text 1"/>
+          <p:cNvSpPr/>
+          <p:nvPr/>
+        </p:nvSpPr>
+        <p:spPr>
+          <a:xfrm>
+            <a:off x="731520" y="786384"/>
+            <a:ext cx="10698480" cy="566928"/>
+          </a:xfrm>
+          <a:prstGeom prst="rect">
+            <a:avLst/>
+          </a:prstGeom>
+          <a:noFill/>
+          <a:ln/>
+        </p:spPr>
+        <p:txBody>
+          <a:bodyPr wrap="square" rtlCol="0" anchor="ctr"/>
+          <a:lstStyle/>
+          <a:p>
+            <a:pPr indent="0" marL="0">
+              <a:buNone/>
+            </a:pPr>
+            <a:r>
+              <a:rPr lang="en-US" sz="2700" b="1" dirty="0">
+                <a:solidFill>
+                  <a:srgbClr val="212933"/>
+                </a:solidFill>
+                <a:latin typeface="Calibri" pitchFamily="34" charset="0"/>
+                <a:ea typeface="Calibri" pitchFamily="34" charset="-122"/>
+                <a:cs typeface="Calibri" pitchFamily="34" charset="-120"/>
+              </a:rPr>
+              <a:t>Deployment view — every hop, end to end</a:t>
+            </a:r>
+            <a:endParaRPr lang="en-US" sz="2700" dirty="0"/>
+          </a:p>
+        </p:txBody>
+      </p:sp>
+      <p:sp>
+        <p:nvSpPr>
+          <p:cNvPr id="4" name="Shape 2"/>
+          <p:cNvSpPr/>
+          <p:nvPr/>
+        </p:nvSpPr>
+        <p:spPr>
+          <a:xfrm>
+            <a:off x="502920" y="1554480"/>
+            <a:ext cx="2286000" cy="4343400"/>
+          </a:xfrm>
+          <a:prstGeom prst="roundRect">
+            <a:avLst>
+              <a:gd name="adj" fmla="val 4000"/>
+            </a:avLst>
+          </a:prstGeom>
+          <a:solidFill>
+            <a:srgbClr val="F5F7F9"/>
+          </a:solidFill>
+          <a:ln w="15875">
+            <a:solidFill>
+              <a:srgbClr val="50708C"/>
+            </a:solidFill>
+            <a:prstDash val="solid"/>
+          </a:ln>
+        </p:spPr>
+      </p:sp>
+      <p:sp>
+        <p:nvSpPr>
+          <p:cNvPr id="5" name="Text 3"/>
+          <p:cNvSpPr/>
+          <p:nvPr/>
+        </p:nvSpPr>
+        <p:spPr>
+          <a:xfrm>
+            <a:off x="649224" y="1618488"/>
+            <a:ext cx="2011680" cy="256032"/>
+          </a:xfrm>
+          <a:prstGeom prst="rect">
+            <a:avLst/>
+          </a:prstGeom>
+          <a:noFill/>
+          <a:ln/>
+        </p:spPr>
+        <p:txBody>
+          <a:bodyPr wrap="square" lIns="0" tIns="0" rIns="0" bIns="0" rtlCol="0" anchor="ctr"/>
+          <a:lstStyle/>
+          <a:p>
+            <a:pPr indent="0" marL="0">
+              <a:buNone/>
+            </a:pPr>
+            <a:r>
+              <a:rPr lang="en-US" sz="950" b="1" spc="150" kern="0" dirty="0">
+                <a:solidFill>
+                  <a:srgbClr val="50708C"/>
+                </a:solidFill>
+                <a:latin typeface="Calibri" pitchFamily="34" charset="0"/>
+                <a:ea typeface="Calibri" pitchFamily="34" charset="-122"/>
+                <a:cs typeface="Calibri" pitchFamily="34" charset="-120"/>
+              </a:rPr>
+              <a:t>CLIENTS</a:t>
+            </a:r>
+            <a:endParaRPr lang="en-US" sz="950" dirty="0"/>
+          </a:p>
+        </p:txBody>
+      </p:sp>
+      <p:sp>
+        <p:nvSpPr>
+          <p:cNvPr id="6" name="Shape 4"/>
+          <p:cNvSpPr/>
+          <p:nvPr/>
+        </p:nvSpPr>
+        <p:spPr>
+          <a:xfrm>
+            <a:off x="3246120" y="1554480"/>
+            <a:ext cx="2331720" cy="4343400"/>
+          </a:xfrm>
+          <a:prstGeom prst="roundRect">
+            <a:avLst>
+              <a:gd name="adj" fmla="val 3922"/>
+            </a:avLst>
+          </a:prstGeom>
+          <a:solidFill>
+            <a:srgbClr val="F5F7F9"/>
+          </a:solidFill>
+          <a:ln w="15875">
+            <a:solidFill>
+              <a:srgbClr val="E8590C"/>
+            </a:solidFill>
+            <a:prstDash val="solid"/>
+          </a:ln>
+        </p:spPr>
+      </p:sp>
+      <p:sp>
+        <p:nvSpPr>
+          <p:cNvPr id="7" name="Text 5"/>
+          <p:cNvSpPr/>
+          <p:nvPr/>
+        </p:nvSpPr>
+        <p:spPr>
+          <a:xfrm>
+            <a:off x="3392424" y="1618488"/>
+            <a:ext cx="2057400" cy="256032"/>
+          </a:xfrm>
+          <a:prstGeom prst="rect">
+            <a:avLst/>
+          </a:prstGeom>
+          <a:noFill/>
+          <a:ln/>
+        </p:spPr>
+        <p:txBody>
+          <a:bodyPr wrap="square" lIns="0" tIns="0" rIns="0" bIns="0" rtlCol="0" anchor="ctr"/>
+          <a:lstStyle/>
+          <a:p>
+            <a:pPr indent="0" marL="0">
+              <a:buNone/>
+            </a:pPr>
+            <a:r>
+              <a:rPr lang="en-US" sz="950" b="1" spc="150" kern="0" dirty="0">
+                <a:solidFill>
+                  <a:srgbClr val="E8590C"/>
+                </a:solidFill>
+                <a:latin typeface="Calibri" pitchFamily="34" charset="0"/>
+                <a:ea typeface="Calibri" pitchFamily="34" charset="-122"/>
+                <a:cs typeface="Calibri" pitchFamily="34" charset="-120"/>
+              </a:rPr>
+              <a:t>EDGE &amp; TELEPHONY</a:t>
+            </a:r>
+            <a:endParaRPr lang="en-US" sz="950" dirty="0"/>
+          </a:p>
+        </p:txBody>
+      </p:sp>
+      <p:sp>
+        <p:nvSpPr>
+          <p:cNvPr id="8" name="Shape 6"/>
+          <p:cNvSpPr/>
+          <p:nvPr/>
+        </p:nvSpPr>
+        <p:spPr>
+          <a:xfrm>
+            <a:off x="6035040" y="1554480"/>
+            <a:ext cx="3383280" cy="4343400"/>
+          </a:xfrm>
+          <a:prstGeom prst="roundRect">
+            <a:avLst>
+              <a:gd name="adj" fmla="val 2703"/>
+            </a:avLst>
+          </a:prstGeom>
+          <a:solidFill>
+            <a:srgbClr val="F5F7F9"/>
+          </a:solidFill>
+          <a:ln w="15875">
+            <a:solidFill>
+              <a:srgbClr val="222B36"/>
+            </a:solidFill>
+            <a:prstDash val="solid"/>
+          </a:ln>
+        </p:spPr>
+      </p:sp>
+      <p:sp>
+        <p:nvSpPr>
+          <p:cNvPr id="9" name="Text 7"/>
+          <p:cNvSpPr/>
+          <p:nvPr/>
+        </p:nvSpPr>
+        <p:spPr>
+          <a:xfrm>
+            <a:off x="6181344" y="1618488"/>
+            <a:ext cx="3108960" cy="256032"/>
+          </a:xfrm>
+          <a:prstGeom prst="rect">
+            <a:avLst/>
+          </a:prstGeom>
+          <a:noFill/>
+          <a:ln/>
+        </p:spPr>
+        <p:txBody>
+          <a:bodyPr wrap="square" lIns="0" tIns="0" rIns="0" bIns="0" rtlCol="0" anchor="ctr"/>
+          <a:lstStyle/>
+          <a:p>
+            <a:pPr indent="0" marL="0">
+              <a:buNone/>
+            </a:pPr>
+            <a:r>
+              <a:rPr lang="en-US" sz="950" b="1" spc="150" kern="0" dirty="0">
+                <a:solidFill>
+                  <a:srgbClr val="222B36"/>
+                </a:solidFill>
+                <a:latin typeface="Calibri" pitchFamily="34" charset="0"/>
+                <a:ea typeface="Calibri" pitchFamily="34" charset="-122"/>
+                <a:cs typeface="Calibri" pitchFamily="34" charset="-120"/>
+              </a:rPr>
+              <a:t>APP SERVER — CONTAINERIZED · CLOUD-PORTABLE</a:t>
+            </a:r>
+            <a:endParaRPr lang="en-US" sz="950" dirty="0"/>
+          </a:p>
+        </p:txBody>
+      </p:sp>
+      <p:sp>
+        <p:nvSpPr>
+          <p:cNvPr id="10" name="Shape 8"/>
+          <p:cNvSpPr/>
+          <p:nvPr/>
+        </p:nvSpPr>
+        <p:spPr>
+          <a:xfrm>
+            <a:off x="9875520" y="1554480"/>
+            <a:ext cx="1828800" cy="1965960"/>
+          </a:xfrm>
+          <a:prstGeom prst="roundRect">
+            <a:avLst>
+              <a:gd name="adj" fmla="val 5000"/>
+            </a:avLst>
+          </a:prstGeom>
+          <a:solidFill>
+            <a:srgbClr val="F5F7F9"/>
+          </a:solidFill>
+          <a:ln w="15875">
+            <a:solidFill>
+              <a:srgbClr val="50708C"/>
+            </a:solidFill>
+            <a:prstDash val="solid"/>
+          </a:ln>
+        </p:spPr>
+      </p:sp>
+      <p:sp>
+        <p:nvSpPr>
+          <p:cNvPr id="11" name="Text 9"/>
+          <p:cNvSpPr/>
+          <p:nvPr/>
+        </p:nvSpPr>
+        <p:spPr>
+          <a:xfrm>
+            <a:off x="10021824" y="1618488"/>
+            <a:ext cx="1554480" cy="256032"/>
+          </a:xfrm>
+          <a:prstGeom prst="rect">
+            <a:avLst/>
+          </a:prstGeom>
+          <a:noFill/>
+          <a:ln/>
+        </p:spPr>
+        <p:txBody>
+          <a:bodyPr wrap="square" lIns="0" tIns="0" rIns="0" bIns="0" rtlCol="0" anchor="ctr"/>
+          <a:lstStyle/>
+          <a:p>
+            <a:pPr indent="0" marL="0">
+              <a:buNone/>
+            </a:pPr>
+            <a:r>
+              <a:rPr lang="en-US" sz="950" b="1" spc="150" kern="0" dirty="0">
+                <a:solidFill>
+                  <a:srgbClr val="50708C"/>
+                </a:solidFill>
+                <a:latin typeface="Calibri" pitchFamily="34" charset="0"/>
+                <a:ea typeface="Calibri" pitchFamily="34" charset="-122"/>
+                <a:cs typeface="Calibri" pitchFamily="34" charset="-120"/>
+              </a:rPr>
+              <a:t>AI SAAS</a:t>
+            </a:r>
+            <a:endParaRPr lang="en-US" sz="950" dirty="0"/>
+          </a:p>
+        </p:txBody>
+      </p:sp>
+      <p:sp>
+        <p:nvSpPr>
+          <p:cNvPr id="12" name="Shape 10"/>
+          <p:cNvSpPr/>
+          <p:nvPr/>
+        </p:nvSpPr>
+        <p:spPr>
+          <a:xfrm>
+            <a:off x="9875520" y="3703320"/>
+            <a:ext cx="1828800" cy="2194560"/>
+          </a:xfrm>
+          <a:prstGeom prst="roundRect">
+            <a:avLst>
+              <a:gd name="adj" fmla="val 5000"/>
+            </a:avLst>
+          </a:prstGeom>
+          <a:solidFill>
+            <a:srgbClr val="F5F7F9"/>
+          </a:solidFill>
+          <a:ln w="15875">
+            <a:solidFill>
+              <a:srgbClr val="2FA36B"/>
+            </a:solidFill>
+            <a:prstDash val="solid"/>
+          </a:ln>
+        </p:spPr>
+      </p:sp>
+      <p:sp>
+        <p:nvSpPr>
+          <p:cNvPr id="13" name="Text 11"/>
+          <p:cNvSpPr/>
+          <p:nvPr/>
+        </p:nvSpPr>
+        <p:spPr>
+          <a:xfrm>
+            <a:off x="10021824" y="3767328"/>
+            <a:ext cx="1554480" cy="256032"/>
+          </a:xfrm>
+          <a:prstGeom prst="rect">
+            <a:avLst/>
+          </a:prstGeom>
+          <a:noFill/>
+          <a:ln/>
+        </p:spPr>
+        <p:txBody>
+          <a:bodyPr wrap="square" lIns="0" tIns="0" rIns="0" bIns="0" rtlCol="0" anchor="ctr"/>
+          <a:lstStyle/>
+          <a:p>
+            <a:pPr indent="0" marL="0">
+              <a:buNone/>
+            </a:pPr>
+            <a:r>
+              <a:rPr lang="en-US" sz="950" b="1" spc="150" kern="0" dirty="0">
+                <a:solidFill>
+                  <a:srgbClr val="2FA36B"/>
+                </a:solidFill>
+                <a:latin typeface="Calibri" pitchFamily="34" charset="0"/>
+                <a:ea typeface="Calibri" pitchFamily="34" charset="-122"/>
+                <a:cs typeface="Calibri" pitchFamily="34" charset="-120"/>
+              </a:rPr>
+              <a:t>DATA &amp; VECTORS</a:t>
+            </a:r>
+            <a:endParaRPr lang="en-US" sz="950" dirty="0"/>
+          </a:p>
+        </p:txBody>
+      </p:sp>
+      <p:sp>
+        <p:nvSpPr>
+          <p:cNvPr id="14" name="Shape 12"/>
+          <p:cNvSpPr/>
+          <p:nvPr/>
+        </p:nvSpPr>
+        <p:spPr>
+          <a:xfrm>
+            <a:off x="640080" y="1965960"/>
+            <a:ext cx="2011680" cy="868680"/>
+          </a:xfrm>
+          <a:prstGeom prst="roundRect">
+            <a:avLst>
+              <a:gd name="adj" fmla="val 7368"/>
+            </a:avLst>
+          </a:prstGeom>
+          <a:solidFill>
+            <a:srgbClr val="FFFFFF"/>
+          </a:solidFill>
+          <a:ln w="12700">
+            <a:solidFill>
+              <a:srgbClr val="E0E5EA"/>
+            </a:solidFill>
+            <a:prstDash val="solid"/>
+          </a:ln>
+          <a:effectLst>
+            <a:outerShdw sx="100000" sy="100000" kx="0" ky="0" algn="bl" rotWithShape="0" blurRad="76200" dist="25400" dir="5400000">
+              <a:srgbClr val="1A2027">
+                <a:alpha val="10000"/>
+              </a:srgbClr>
+            </a:outerShdw>
+          </a:effectLst>
+        </p:spPr>
+      </p:sp>
+      <p:sp>
+        <p:nvSpPr>
+          <p:cNvPr id="15" name="Shape 13"/>
+          <p:cNvSpPr/>
+          <p:nvPr/>
+        </p:nvSpPr>
+        <p:spPr>
+          <a:xfrm>
+            <a:off x="749808" y="2066544"/>
+            <a:ext cx="310896" cy="310896"/>
+          </a:xfrm>
+          <a:prstGeom prst="ellipse">
+            <a:avLst/>
+          </a:prstGeom>
+          <a:solidFill>
+            <a:srgbClr val="50708C"/>
+          </a:solidFill>
+          <a:ln/>
+          <a:effectLst>
+            <a:outerShdw sx="100000" sy="100000" kx="0" ky="0" algn="bl" rotWithShape="0" blurRad="127000" dist="38100" dir="5400000">
+              <a:srgbClr val="1A2027">
+                <a:alpha val="22000"/>
+              </a:srgbClr>
+            </a:outerShdw>
+          </a:effectLst>
+        </p:spPr>
+      </p:sp>
+      <p:pic>
+        <p:nvPicPr>
+          <p:cNvPr id="16" name="Image 0" descr="preencoded.png">    </p:cNvPr>
+          <p:cNvPicPr>
+            <a:picLocks noChangeAspect="1"/>
+          </p:cNvPicPr>
+          <p:nvPr/>
+        </p:nvPicPr>
+        <p:blipFill>
+          <a:blip r:embed="rId1"/>
+          <a:stretch>
+            <a:fillRect/>
+          </a:stretch>
+        </p:blipFill>
+        <p:spPr>
+          <a:xfrm>
+            <a:off x="824423" y="2141159"/>
+            <a:ext cx="161666" cy="161666"/>
+          </a:xfrm>
+          <a:prstGeom prst="rect">
+            <a:avLst/>
+          </a:prstGeom>
+        </p:spPr>
+      </p:pic>
+      <p:sp>
+        <p:nvSpPr>
+          <p:cNvPr id="17" name="Text 14"/>
+          <p:cNvSpPr/>
+          <p:nvPr/>
+        </p:nvSpPr>
+        <p:spPr>
+          <a:xfrm>
+            <a:off x="1152144" y="2020824"/>
+            <a:ext cx="1408176" cy="292608"/>
+          </a:xfrm>
+          <a:prstGeom prst="rect">
+            <a:avLst/>
+          </a:prstGeom>
+          <a:noFill/>
+          <a:ln/>
+        </p:spPr>
+        <p:txBody>
+          <a:bodyPr wrap="square" lIns="0" tIns="0" rIns="0" bIns="0" rtlCol="0" anchor="ctr"/>
+          <a:lstStyle/>
+          <a:p>
+            <a:pPr indent="0" marL="0">
+              <a:buNone/>
+            </a:pPr>
+            <a:r>
+              <a:rPr lang="en-US" sz="1050" b="1" dirty="0">
+                <a:solidFill>
+                  <a:srgbClr val="212933"/>
+                </a:solidFill>
+                <a:latin typeface="Calibri" pitchFamily="34" charset="0"/>
+                <a:ea typeface="Calibri" pitchFamily="34" charset="-122"/>
+                <a:cs typeface="Calibri" pitchFamily="34" charset="-120"/>
+              </a:rPr>
+              <a:t>Supervisor browser</a:t>
+            </a:r>
+            <a:endParaRPr lang="en-US" sz="1050" dirty="0"/>
+          </a:p>
+        </p:txBody>
+      </p:sp>
+      <p:sp>
+        <p:nvSpPr>
+          <p:cNvPr id="18" name="Text 15"/>
+          <p:cNvSpPr/>
+          <p:nvPr/>
+        </p:nvSpPr>
+        <p:spPr>
+          <a:xfrm>
+            <a:off x="768096" y="2368296"/>
+            <a:ext cx="1773936" cy="429768"/>
+          </a:xfrm>
+          <a:prstGeom prst="rect">
+            <a:avLst/>
+          </a:prstGeom>
+          <a:noFill/>
+          <a:ln/>
+        </p:spPr>
+        <p:txBody>
+          <a:bodyPr wrap="square" lIns="0" tIns="0" rIns="0" bIns="0" rtlCol="0" anchor="ctr"/>
+          <a:lstStyle/>
+          <a:p>
+            <a:pPr indent="0" marL="0">
+              <a:lnSpc>
+                <a:spcPct val="98000"/>
+              </a:lnSpc>
+              <a:buNone/>
+            </a:pPr>
+            <a:r>
+              <a:rPr lang="en-US" sz="850" dirty="0">
+                <a:solidFill>
+                  <a:srgbClr val="5C6B7A"/>
+                </a:solidFill>
+                <a:latin typeface="Calibri" pitchFamily="34" charset="0"/>
+                <a:ea typeface="Calibri" pitchFamily="34" charset="-122"/>
+                <a:cs typeface="Calibri" pitchFamily="34" charset="-120"/>
+              </a:rPr>
+              <a:t>floor view · alert feed (SSE) · rules &amp; QA admin</a:t>
+            </a:r>
+            <a:endParaRPr lang="en-US" sz="850" dirty="0"/>
+          </a:p>
+        </p:txBody>
+      </p:sp>
+      <p:sp>
+        <p:nvSpPr>
+          <p:cNvPr id="19" name="Shape 16"/>
+          <p:cNvSpPr/>
+          <p:nvPr/>
+        </p:nvSpPr>
+        <p:spPr>
+          <a:xfrm>
+            <a:off x="640080" y="3017520"/>
+            <a:ext cx="2011680" cy="868680"/>
+          </a:xfrm>
+          <a:prstGeom prst="roundRect">
+            <a:avLst>
+              <a:gd name="adj" fmla="val 7368"/>
+            </a:avLst>
+          </a:prstGeom>
+          <a:solidFill>
+            <a:srgbClr val="FFFFFF"/>
+          </a:solidFill>
+          <a:ln w="12700">
+            <a:solidFill>
+              <a:srgbClr val="E0E5EA"/>
+            </a:solidFill>
+            <a:prstDash val="solid"/>
+          </a:ln>
+          <a:effectLst>
+            <a:outerShdw sx="100000" sy="100000" kx="0" ky="0" algn="bl" rotWithShape="0" blurRad="76200" dist="25400" dir="5400000">
+              <a:srgbClr val="1A2027">
+                <a:alpha val="10000"/>
+              </a:srgbClr>
+            </a:outerShdw>
+          </a:effectLst>
+        </p:spPr>
+      </p:sp>
+      <p:sp>
+        <p:nvSpPr>
+          <p:cNvPr id="20" name="Shape 17"/>
+          <p:cNvSpPr/>
+          <p:nvPr/>
+        </p:nvSpPr>
+        <p:spPr>
+          <a:xfrm>
+            <a:off x="749808" y="3118104"/>
+            <a:ext cx="310896" cy="310896"/>
+          </a:xfrm>
+          <a:prstGeom prst="ellipse">
+            <a:avLst/>
+          </a:prstGeom>
+          <a:solidFill>
+            <a:srgbClr val="E8590C"/>
+          </a:solidFill>
+          <a:ln/>
+          <a:effectLst>
+            <a:outerShdw sx="100000" sy="100000" kx="0" ky="0" algn="bl" rotWithShape="0" blurRad="127000" dist="38100" dir="5400000">
+              <a:srgbClr val="1A2027">
+                <a:alpha val="22000"/>
+              </a:srgbClr>
+            </a:outerShdw>
+          </a:effectLst>
+        </p:spPr>
+      </p:sp>
+      <p:pic>
+        <p:nvPicPr>
+          <p:cNvPr id="21" name="Image 1" descr="preencoded.png">    </p:cNvPr>
+          <p:cNvPicPr>
+            <a:picLocks noChangeAspect="1"/>
+          </p:cNvPicPr>
+          <p:nvPr/>
+        </p:nvPicPr>
+        <p:blipFill>
+          <a:blip r:embed="rId2"/>
+          <a:stretch>
+            <a:fillRect/>
+          </a:stretch>
+        </p:blipFill>
+        <p:spPr>
+          <a:xfrm>
+            <a:off x="824423" y="3192719"/>
+            <a:ext cx="161666" cy="161666"/>
+          </a:xfrm>
+          <a:prstGeom prst="rect">
+            <a:avLst/>
+          </a:prstGeom>
+        </p:spPr>
+      </p:pic>
+      <p:sp>
+        <p:nvSpPr>
+          <p:cNvPr id="22" name="Text 18"/>
+          <p:cNvSpPr/>
+          <p:nvPr/>
+        </p:nvSpPr>
+        <p:spPr>
+          <a:xfrm>
+            <a:off x="1152144" y="3072384"/>
+            <a:ext cx="1408176" cy="292608"/>
+          </a:xfrm>
+          <a:prstGeom prst="rect">
+            <a:avLst/>
+          </a:prstGeom>
+          <a:noFill/>
+          <a:ln/>
+        </p:spPr>
+        <p:txBody>
+          <a:bodyPr wrap="square" lIns="0" tIns="0" rIns="0" bIns="0" rtlCol="0" anchor="ctr"/>
+          <a:lstStyle/>
+          <a:p>
+            <a:pPr indent="0" marL="0">
+              <a:buNone/>
+            </a:pPr>
+            <a:r>
+              <a:rPr lang="en-US" sz="1050" b="1" dirty="0">
+                <a:solidFill>
+                  <a:srgbClr val="212933"/>
+                </a:solidFill>
+                <a:latin typeface="Calibri" pitchFamily="34" charset="0"/>
+                <a:ea typeface="Calibri" pitchFamily="34" charset="-122"/>
+                <a:cs typeface="Calibri" pitchFamily="34" charset="-120"/>
+              </a:rPr>
+              <a:t>Agent browser</a:t>
+            </a:r>
+            <a:endParaRPr lang="en-US" sz="1050" dirty="0"/>
+          </a:p>
+        </p:txBody>
+      </p:sp>
+      <p:sp>
+        <p:nvSpPr>
+          <p:cNvPr id="23" name="Text 19"/>
+          <p:cNvSpPr/>
+          <p:nvPr/>
+        </p:nvSpPr>
+        <p:spPr>
+          <a:xfrm>
+            <a:off x="768096" y="3419856"/>
+            <a:ext cx="1773936" cy="429768"/>
+          </a:xfrm>
+          <a:prstGeom prst="rect">
+            <a:avLst/>
+          </a:prstGeom>
+          <a:noFill/>
+          <a:ln/>
+        </p:spPr>
+        <p:txBody>
+          <a:bodyPr wrap="square" lIns="0" tIns="0" rIns="0" bIns="0" rtlCol="0" anchor="ctr"/>
+          <a:lstStyle/>
+          <a:p>
+            <a:pPr indent="0" marL="0">
+              <a:lnSpc>
+                <a:spcPct val="98000"/>
+              </a:lnSpc>
+              <a:buNone/>
+            </a:pPr>
+            <a:r>
+              <a:rPr lang="en-US" sz="850" dirty="0">
+                <a:solidFill>
+                  <a:srgbClr val="5C6B7A"/>
+                </a:solidFill>
+                <a:latin typeface="Calibri" pitchFamily="34" charset="0"/>
+                <a:ea typeface="Calibri" pitchFamily="34" charset="-122"/>
+                <a:cs typeface="Calibri" pitchFamily="34" charset="-120"/>
+              </a:rPr>
+              <a:t>React SPA · Twilio Voice SDK · call panel + Atlas</a:t>
+            </a:r>
+            <a:endParaRPr lang="en-US" sz="850" dirty="0"/>
+          </a:p>
+        </p:txBody>
+      </p:sp>
+      <p:sp>
+        <p:nvSpPr>
+          <p:cNvPr id="24" name="Shape 20"/>
+          <p:cNvSpPr/>
+          <p:nvPr/>
+        </p:nvSpPr>
+        <p:spPr>
+          <a:xfrm>
+            <a:off x="640080" y="4069080"/>
+            <a:ext cx="2011680" cy="868680"/>
+          </a:xfrm>
+          <a:prstGeom prst="roundRect">
+            <a:avLst>
+              <a:gd name="adj" fmla="val 7368"/>
+            </a:avLst>
+          </a:prstGeom>
+          <a:solidFill>
+            <a:srgbClr val="FFFFFF"/>
+          </a:solidFill>
+          <a:ln w="12700">
+            <a:solidFill>
+              <a:srgbClr val="E0E5EA"/>
+            </a:solidFill>
+            <a:prstDash val="solid"/>
+          </a:ln>
+          <a:effectLst>
+            <a:outerShdw sx="100000" sy="100000" kx="0" ky="0" algn="bl" rotWithShape="0" blurRad="76200" dist="25400" dir="5400000">
+              <a:srgbClr val="1A2027">
+                <a:alpha val="10000"/>
+              </a:srgbClr>
+            </a:outerShdw>
+          </a:effectLst>
+        </p:spPr>
+      </p:sp>
+      <p:sp>
+        <p:nvSpPr>
+          <p:cNvPr id="25" name="Shape 21"/>
+          <p:cNvSpPr/>
+          <p:nvPr/>
+        </p:nvSpPr>
+        <p:spPr>
+          <a:xfrm>
+            <a:off x="749808" y="4169664"/>
+            <a:ext cx="310896" cy="310896"/>
+          </a:xfrm>
+          <a:prstGeom prst="ellipse">
+            <a:avLst/>
+          </a:prstGeom>
+          <a:solidFill>
+            <a:srgbClr val="3C4857"/>
+          </a:solidFill>
+          <a:ln/>
+          <a:effectLst>
+            <a:outerShdw sx="100000" sy="100000" kx="0" ky="0" algn="bl" rotWithShape="0" blurRad="127000" dist="38100" dir="5400000">
+              <a:srgbClr val="1A2027">
+                <a:alpha val="22000"/>
+              </a:srgbClr>
+            </a:outerShdw>
+          </a:effectLst>
+        </p:spPr>
+      </p:sp>
+      <p:pic>
+        <p:nvPicPr>
+          <p:cNvPr id="26" name="Image 2" descr="preencoded.png">    </p:cNvPr>
+          <p:cNvPicPr>
+            <a:picLocks noChangeAspect="1"/>
+          </p:cNvPicPr>
+          <p:nvPr/>
+        </p:nvPicPr>
+        <p:blipFill>
+          <a:blip r:embed="rId3"/>
+          <a:stretch>
+            <a:fillRect/>
+          </a:stretch>
+        </p:blipFill>
+        <p:spPr>
+          <a:xfrm>
+            <a:off x="824423" y="4244279"/>
+            <a:ext cx="161666" cy="161666"/>
+          </a:xfrm>
+          <a:prstGeom prst="rect">
+            <a:avLst/>
+          </a:prstGeom>
+        </p:spPr>
+      </p:pic>
+      <p:sp>
+        <p:nvSpPr>
+          <p:cNvPr id="27" name="Text 22"/>
+          <p:cNvSpPr/>
+          <p:nvPr/>
+        </p:nvSpPr>
+        <p:spPr>
+          <a:xfrm>
+            <a:off x="1152144" y="4123944"/>
+            <a:ext cx="1408176" cy="292608"/>
+          </a:xfrm>
+          <a:prstGeom prst="rect">
+            <a:avLst/>
+          </a:prstGeom>
+          <a:noFill/>
+          <a:ln/>
+        </p:spPr>
+        <p:txBody>
+          <a:bodyPr wrap="square" lIns="0" tIns="0" rIns="0" bIns="0" rtlCol="0" anchor="ctr"/>
+          <a:lstStyle/>
+          <a:p>
+            <a:pPr indent="0" marL="0">
+              <a:buNone/>
+            </a:pPr>
+            <a:r>
+              <a:rPr lang="en-US" sz="1050" b="1" dirty="0">
+                <a:solidFill>
+                  <a:srgbClr val="212933"/>
+                </a:solidFill>
+                <a:latin typeface="Calibri" pitchFamily="34" charset="0"/>
+                <a:ea typeface="Calibri" pitchFamily="34" charset="-122"/>
+                <a:cs typeface="Calibri" pitchFamily="34" charset="-120"/>
+              </a:rPr>
+              <a:t>Prospect phone</a:t>
+            </a:r>
+            <a:endParaRPr lang="en-US" sz="1050" dirty="0"/>
+          </a:p>
+        </p:txBody>
+      </p:sp>
+      <p:sp>
+        <p:nvSpPr>
+          <p:cNvPr id="28" name="Text 23"/>
+          <p:cNvSpPr/>
+          <p:nvPr/>
+        </p:nvSpPr>
+        <p:spPr>
+          <a:xfrm>
+            <a:off x="768096" y="4471416"/>
+            <a:ext cx="1773936" cy="429768"/>
+          </a:xfrm>
+          <a:prstGeom prst="rect">
+            <a:avLst/>
+          </a:prstGeom>
+          <a:noFill/>
+          <a:ln/>
+        </p:spPr>
+        <p:txBody>
+          <a:bodyPr wrap="square" lIns="0" tIns="0" rIns="0" bIns="0" rtlCol="0" anchor="ctr"/>
+          <a:lstStyle/>
+          <a:p>
+            <a:pPr indent="0" marL="0">
+              <a:lnSpc>
+                <a:spcPct val="98000"/>
+              </a:lnSpc>
+              <a:buNone/>
+            </a:pPr>
+            <a:r>
+              <a:rPr lang="en-US" sz="850" dirty="0">
+                <a:solidFill>
+                  <a:srgbClr val="5C6B7A"/>
+                </a:solidFill>
+                <a:latin typeface="Calibri" pitchFamily="34" charset="0"/>
+                <a:ea typeface="Calibri" pitchFamily="34" charset="-122"/>
+                <a:cs typeface="Calibri" pitchFamily="34" charset="-120"/>
+              </a:rPr>
+              <a:t>PSTN — inbound &amp; outbound calls</a:t>
+            </a:r>
+            <a:endParaRPr lang="en-US" sz="850" dirty="0"/>
+          </a:p>
+        </p:txBody>
+      </p:sp>
+      <p:sp>
+        <p:nvSpPr>
+          <p:cNvPr id="29" name="Shape 24"/>
+          <p:cNvSpPr/>
+          <p:nvPr/>
+        </p:nvSpPr>
+        <p:spPr>
+          <a:xfrm>
+            <a:off x="3383280" y="1965960"/>
+            <a:ext cx="2057400" cy="1188720"/>
+          </a:xfrm>
+          <a:prstGeom prst="roundRect">
+            <a:avLst>
+              <a:gd name="adj" fmla="val 5385"/>
+            </a:avLst>
+          </a:prstGeom>
+          <a:solidFill>
+            <a:srgbClr val="FFFFFF"/>
+          </a:solidFill>
+          <a:ln w="12700">
+            <a:solidFill>
+              <a:srgbClr val="E0E5EA"/>
+            </a:solidFill>
+            <a:prstDash val="solid"/>
+          </a:ln>
+          <a:effectLst>
+            <a:outerShdw sx="100000" sy="100000" kx="0" ky="0" algn="bl" rotWithShape="0" blurRad="76200" dist="25400" dir="5400000">
+              <a:srgbClr val="1A2027">
+                <a:alpha val="10000"/>
+              </a:srgbClr>
+            </a:outerShdw>
+          </a:effectLst>
+        </p:spPr>
+      </p:sp>
+      <p:sp>
+        <p:nvSpPr>
+          <p:cNvPr id="30" name="Shape 25"/>
+          <p:cNvSpPr/>
+          <p:nvPr/>
+        </p:nvSpPr>
+        <p:spPr>
+          <a:xfrm>
+            <a:off x="3493008" y="2066544"/>
+            <a:ext cx="310896" cy="310896"/>
+          </a:xfrm>
+          <a:prstGeom prst="ellipse">
+            <a:avLst/>
+          </a:prstGeom>
+          <a:solidFill>
+            <a:srgbClr val="E8590C"/>
+          </a:solidFill>
+          <a:ln/>
+          <a:effectLst>
+            <a:outerShdw sx="100000" sy="100000" kx="0" ky="0" algn="bl" rotWithShape="0" blurRad="127000" dist="38100" dir="5400000">
+              <a:srgbClr val="1A2027">
+                <a:alpha val="22000"/>
+              </a:srgbClr>
+            </a:outerShdw>
+          </a:effectLst>
+        </p:spPr>
+      </p:sp>
+      <p:pic>
+        <p:nvPicPr>
+          <p:cNvPr id="31" name="Image 3" descr="preencoded.png">    </p:cNvPr>
+          <p:cNvPicPr>
+            <a:picLocks noChangeAspect="1"/>
+          </p:cNvPicPr>
+          <p:nvPr/>
+        </p:nvPicPr>
+        <p:blipFill>
+          <a:blip r:embed="rId4"/>
+          <a:stretch>
+            <a:fillRect/>
+          </a:stretch>
+        </p:blipFill>
+        <p:spPr>
+          <a:xfrm>
+            <a:off x="3567623" y="2141159"/>
+            <a:ext cx="161666" cy="161666"/>
+          </a:xfrm>
+          <a:prstGeom prst="rect">
+            <a:avLst/>
+          </a:prstGeom>
+        </p:spPr>
+      </p:pic>
+      <p:sp>
+        <p:nvSpPr>
+          <p:cNvPr id="32" name="Text 26"/>
+          <p:cNvSpPr/>
+          <p:nvPr/>
+        </p:nvSpPr>
+        <p:spPr>
+          <a:xfrm>
+            <a:off x="3895344" y="2020824"/>
+            <a:ext cx="1453896" cy="292608"/>
+          </a:xfrm>
+          <a:prstGeom prst="rect">
+            <a:avLst/>
+          </a:prstGeom>
+          <a:noFill/>
+          <a:ln/>
+        </p:spPr>
+        <p:txBody>
+          <a:bodyPr wrap="square" lIns="0" tIns="0" rIns="0" bIns="0" rtlCol="0" anchor="ctr"/>
+          <a:lstStyle/>
+          <a:p>
+            <a:pPr indent="0" marL="0">
+              <a:buNone/>
+            </a:pPr>
+            <a:r>
+              <a:rPr lang="en-US" sz="1050" b="1" dirty="0">
+                <a:solidFill>
+                  <a:srgbClr val="212933"/>
+                </a:solidFill>
+                <a:latin typeface="Calibri" pitchFamily="34" charset="0"/>
+                <a:ea typeface="Calibri" pitchFamily="34" charset="-122"/>
+                <a:cs typeface="Calibri" pitchFamily="34" charset="-120"/>
+              </a:rPr>
+              <a:t>Cloudflare edge</a:t>
+            </a:r>
+            <a:endParaRPr lang="en-US" sz="1050" dirty="0"/>
+          </a:p>
+        </p:txBody>
+      </p:sp>
+      <p:sp>
+        <p:nvSpPr>
+          <p:cNvPr id="33" name="Text 27"/>
+          <p:cNvSpPr/>
+          <p:nvPr/>
+        </p:nvSpPr>
+        <p:spPr>
+          <a:xfrm>
+            <a:off x="3511296" y="2368296"/>
+            <a:ext cx="1819656" cy="749808"/>
+          </a:xfrm>
+          <a:prstGeom prst="rect">
+            <a:avLst/>
+          </a:prstGeom>
+          <a:noFill/>
+          <a:ln/>
+        </p:spPr>
+        <p:txBody>
+          <a:bodyPr wrap="square" lIns="0" tIns="0" rIns="0" bIns="0" rtlCol="0" anchor="ctr"/>
+          <a:lstStyle/>
+          <a:p>
+            <a:pPr indent="0" marL="0">
+              <a:lnSpc>
+                <a:spcPct val="98000"/>
+              </a:lnSpc>
+              <a:buNone/>
+            </a:pPr>
+            <a:r>
+              <a:rPr lang="en-US" sz="850" dirty="0">
+                <a:solidFill>
+                  <a:srgbClr val="5C6B7A"/>
+                </a:solidFill>
+                <a:latin typeface="Calibri" pitchFamily="34" charset="0"/>
+                <a:ea typeface="Calibri" pitchFamily="34" charset="-122"/>
+                <a:cs typeface="Calibri" pitchFamily="34" charset="-120"/>
+              </a:rPr>
+              <a:t>public DNS · TLS termination · named tunnel entry — stable custom domain</a:t>
+            </a:r>
+            <a:endParaRPr lang="en-US" sz="850" dirty="0"/>
+          </a:p>
+        </p:txBody>
+      </p:sp>
+      <p:sp>
+        <p:nvSpPr>
+          <p:cNvPr id="34" name="Shape 28"/>
+          <p:cNvSpPr/>
+          <p:nvPr/>
+        </p:nvSpPr>
+        <p:spPr>
+          <a:xfrm>
+            <a:off x="3383280" y="3566160"/>
+            <a:ext cx="2057400" cy="1371600"/>
+          </a:xfrm>
+          <a:prstGeom prst="roundRect">
+            <a:avLst>
+              <a:gd name="adj" fmla="val 4667"/>
+            </a:avLst>
+          </a:prstGeom>
+          <a:solidFill>
+            <a:srgbClr val="FFFFFF"/>
+          </a:solidFill>
+          <a:ln w="12700">
+            <a:solidFill>
+              <a:srgbClr val="E0E5EA"/>
+            </a:solidFill>
+            <a:prstDash val="solid"/>
+          </a:ln>
+          <a:effectLst>
+            <a:outerShdw sx="100000" sy="100000" kx="0" ky="0" algn="bl" rotWithShape="0" blurRad="76200" dist="25400" dir="5400000">
+              <a:srgbClr val="1A2027">
+                <a:alpha val="10000"/>
+              </a:srgbClr>
+            </a:outerShdw>
+          </a:effectLst>
+        </p:spPr>
+      </p:sp>
+      <p:sp>
+        <p:nvSpPr>
+          <p:cNvPr id="35" name="Shape 29"/>
+          <p:cNvSpPr/>
+          <p:nvPr/>
+        </p:nvSpPr>
+        <p:spPr>
+          <a:xfrm>
+            <a:off x="3493008" y="3666744"/>
+            <a:ext cx="310896" cy="310896"/>
+          </a:xfrm>
+          <a:prstGeom prst="ellipse">
+            <a:avLst/>
+          </a:prstGeom>
+          <a:solidFill>
+            <a:srgbClr val="C0392B"/>
+          </a:solidFill>
+          <a:ln/>
+          <a:effectLst>
+            <a:outerShdw sx="100000" sy="100000" kx="0" ky="0" algn="bl" rotWithShape="0" blurRad="127000" dist="38100" dir="5400000">
+              <a:srgbClr val="1A2027">
+                <a:alpha val="22000"/>
+              </a:srgbClr>
+            </a:outerShdw>
+          </a:effectLst>
+        </p:spPr>
+      </p:sp>
+      <p:pic>
+        <p:nvPicPr>
+          <p:cNvPr id="36" name="Image 4" descr="preencoded.png">    </p:cNvPr>
+          <p:cNvPicPr>
+            <a:picLocks noChangeAspect="1"/>
+          </p:cNvPicPr>
+          <p:nvPr/>
+        </p:nvPicPr>
+        <p:blipFill>
+          <a:blip r:embed="rId5"/>
+          <a:stretch>
+            <a:fillRect/>
+          </a:stretch>
+        </p:blipFill>
+        <p:spPr>
+          <a:xfrm>
+            <a:off x="3567623" y="3741359"/>
+            <a:ext cx="161666" cy="161666"/>
+          </a:xfrm>
+          <a:prstGeom prst="rect">
+            <a:avLst/>
+          </a:prstGeom>
+        </p:spPr>
+      </p:pic>
+      <p:sp>
+        <p:nvSpPr>
+          <p:cNvPr id="37" name="Text 30"/>
+          <p:cNvSpPr/>
+          <p:nvPr/>
+        </p:nvSpPr>
+        <p:spPr>
+          <a:xfrm>
+            <a:off x="3895344" y="3621024"/>
+            <a:ext cx="1453896" cy="292608"/>
+          </a:xfrm>
+          <a:prstGeom prst="rect">
+            <a:avLst/>
+          </a:prstGeom>
+          <a:noFill/>
+          <a:ln/>
+        </p:spPr>
+        <p:txBody>
+          <a:bodyPr wrap="square" lIns="0" tIns="0" rIns="0" bIns="0" rtlCol="0" anchor="ctr"/>
+          <a:lstStyle/>
+          <a:p>
+            <a:pPr indent="0" marL="0">
+              <a:buNone/>
+            </a:pPr>
+            <a:r>
+              <a:rPr lang="en-US" sz="1050" b="1" dirty="0">
+                <a:solidFill>
+                  <a:srgbClr val="212933"/>
+                </a:solidFill>
+                <a:latin typeface="Calibri" pitchFamily="34" charset="0"/>
+                <a:ea typeface="Calibri" pitchFamily="34" charset="-122"/>
+                <a:cs typeface="Calibri" pitchFamily="34" charset="-120"/>
+              </a:rPr>
+              <a:t>Twilio Cloud</a:t>
+            </a:r>
+            <a:endParaRPr lang="en-US" sz="1050" dirty="0"/>
+          </a:p>
+        </p:txBody>
+      </p:sp>
+      <p:sp>
+        <p:nvSpPr>
+          <p:cNvPr id="38" name="Text 31"/>
+          <p:cNvSpPr/>
+          <p:nvPr/>
+        </p:nvSpPr>
+        <p:spPr>
+          <a:xfrm>
+            <a:off x="3511296" y="3968496"/>
+            <a:ext cx="1819656" cy="932688"/>
+          </a:xfrm>
+          <a:prstGeom prst="rect">
+            <a:avLst/>
+          </a:prstGeom>
+          <a:noFill/>
+          <a:ln/>
+        </p:spPr>
+        <p:txBody>
+          <a:bodyPr wrap="square" lIns="0" tIns="0" rIns="0" bIns="0" rtlCol="0" anchor="ctr"/>
+          <a:lstStyle/>
+          <a:p>
+            <a:pPr indent="0" marL="0">
+              <a:lnSpc>
+                <a:spcPct val="98000"/>
+              </a:lnSpc>
+              <a:buNone/>
+            </a:pPr>
+            <a:r>
+              <a:rPr lang="en-US" sz="850" dirty="0">
+                <a:solidFill>
+                  <a:srgbClr val="5C6B7A"/>
+                </a:solidFill>
+                <a:latin typeface="Calibri" pitchFamily="34" charset="0"/>
+                <a:ea typeface="Calibri" pitchFamily="34" charset="-122"/>
+                <a:cs typeface="Calibri" pitchFamily="34" charset="-120"/>
+              </a:rPr>
+              <a:t>TwiML app (outbound) · phone number (inbound) · bidirectional media streams · signed webhooks</a:t>
+            </a:r>
+            <a:endParaRPr lang="en-US" sz="850" dirty="0"/>
+          </a:p>
+        </p:txBody>
+      </p:sp>
+      <p:sp>
+        <p:nvSpPr>
+          <p:cNvPr id="39" name="Shape 32"/>
+          <p:cNvSpPr/>
+          <p:nvPr/>
+        </p:nvSpPr>
+        <p:spPr>
+          <a:xfrm>
+            <a:off x="6172200" y="1920240"/>
+            <a:ext cx="3108960" cy="566928"/>
+          </a:xfrm>
+          <a:prstGeom prst="roundRect">
+            <a:avLst>
+              <a:gd name="adj" fmla="val 11290"/>
+            </a:avLst>
+          </a:prstGeom>
+          <a:solidFill>
+            <a:srgbClr val="FFFFFF"/>
+          </a:solidFill>
+          <a:ln w="12700">
+            <a:solidFill>
+              <a:srgbClr val="E0E5EA"/>
+            </a:solidFill>
+            <a:prstDash val="solid"/>
+          </a:ln>
+          <a:effectLst>
+            <a:outerShdw sx="100000" sy="100000" kx="0" ky="0" algn="bl" rotWithShape="0" blurRad="76200" dist="25400" dir="5400000">
+              <a:srgbClr val="1A2027">
+                <a:alpha val="10000"/>
+              </a:srgbClr>
+            </a:outerShdw>
+          </a:effectLst>
+        </p:spPr>
+      </p:sp>
+      <p:sp>
+        <p:nvSpPr>
+          <p:cNvPr id="40" name="Shape 33"/>
+          <p:cNvSpPr/>
+          <p:nvPr/>
+        </p:nvSpPr>
+        <p:spPr>
+          <a:xfrm>
+            <a:off x="6281928" y="2020824"/>
+            <a:ext cx="310896" cy="310896"/>
+          </a:xfrm>
+          <a:prstGeom prst="ellipse">
+            <a:avLst/>
+          </a:prstGeom>
+          <a:solidFill>
+            <a:srgbClr val="E8590C"/>
+          </a:solidFill>
+          <a:ln/>
+          <a:effectLst>
+            <a:outerShdw sx="100000" sy="100000" kx="0" ky="0" algn="bl" rotWithShape="0" blurRad="127000" dist="38100" dir="5400000">
+              <a:srgbClr val="1A2027">
+                <a:alpha val="22000"/>
+              </a:srgbClr>
+            </a:outerShdw>
+          </a:effectLst>
+        </p:spPr>
+      </p:sp>
+      <p:pic>
+        <p:nvPicPr>
+          <p:cNvPr id="41" name="Image 5" descr="preencoded.png">    </p:cNvPr>
+          <p:cNvPicPr>
+            <a:picLocks noChangeAspect="1"/>
+          </p:cNvPicPr>
+          <p:nvPr/>
+        </p:nvPicPr>
+        <p:blipFill>
+          <a:blip r:embed="rId6"/>
+          <a:stretch>
+            <a:fillRect/>
+          </a:stretch>
+        </p:blipFill>
+        <p:spPr>
+          <a:xfrm>
+            <a:off x="6356543" y="2095439"/>
+            <a:ext cx="161666" cy="161666"/>
+          </a:xfrm>
+          <a:prstGeom prst="rect">
+            <a:avLst/>
+          </a:prstGeom>
+        </p:spPr>
+      </p:pic>
+      <p:sp>
+        <p:nvSpPr>
+          <p:cNvPr id="42" name="Text 34"/>
+          <p:cNvSpPr/>
+          <p:nvPr/>
+        </p:nvSpPr>
+        <p:spPr>
+          <a:xfrm>
+            <a:off x="6684264" y="1975104"/>
+            <a:ext cx="2505456" cy="292608"/>
+          </a:xfrm>
+          <a:prstGeom prst="rect">
+            <a:avLst/>
+          </a:prstGeom>
+          <a:noFill/>
+          <a:ln/>
+        </p:spPr>
+        <p:txBody>
+          <a:bodyPr wrap="square" lIns="0" tIns="0" rIns="0" bIns="0" rtlCol="0" anchor="ctr"/>
+          <a:lstStyle/>
+          <a:p>
+            <a:pPr indent="0" marL="0">
+              <a:buNone/>
+            </a:pPr>
+            <a:r>
+              <a:rPr lang="en-US" sz="1050" b="1" dirty="0">
+                <a:solidFill>
+                  <a:srgbClr val="212933"/>
+                </a:solidFill>
+                <a:latin typeface="Calibri" pitchFamily="34" charset="0"/>
+                <a:ea typeface="Calibri" pitchFamily="34" charset="-122"/>
+                <a:cs typeface="Calibri" pitchFamily="34" charset="-120"/>
+              </a:rPr>
+              <a:t>Tunnel connector</a:t>
+            </a:r>
+            <a:endParaRPr lang="en-US" sz="1050" dirty="0"/>
+          </a:p>
+        </p:txBody>
+      </p:sp>
+      <p:sp>
+        <p:nvSpPr>
+          <p:cNvPr id="43" name="Text 35"/>
+          <p:cNvSpPr/>
+          <p:nvPr/>
+        </p:nvSpPr>
+        <p:spPr>
+          <a:xfrm>
+            <a:off x="6300216" y="2322576"/>
+            <a:ext cx="2871216" cy="128016"/>
+          </a:xfrm>
+          <a:prstGeom prst="rect">
+            <a:avLst/>
+          </a:prstGeom>
+          <a:noFill/>
+          <a:ln/>
+        </p:spPr>
+        <p:txBody>
+          <a:bodyPr wrap="square" lIns="0" tIns="0" rIns="0" bIns="0" rtlCol="0" anchor="ctr"/>
+          <a:lstStyle/>
+          <a:p>
+            <a:pPr indent="0" marL="0">
+              <a:lnSpc>
+                <a:spcPct val="98000"/>
+              </a:lnSpc>
+              <a:buNone/>
+            </a:pPr>
+            <a:r>
+              <a:rPr lang="en-US" sz="850" dirty="0">
+                <a:solidFill>
+                  <a:srgbClr val="5C6B7A"/>
+                </a:solidFill>
+                <a:latin typeface="Calibri" pitchFamily="34" charset="0"/>
+                <a:ea typeface="Calibri" pitchFamily="34" charset="-122"/>
+                <a:cs typeface="Calibri" pitchFamily="34" charset="-120"/>
+              </a:rPr>
+              <a:t>outbound-only — zero open inbound ports</a:t>
+            </a:r>
+            <a:endParaRPr lang="en-US" sz="850" dirty="0"/>
+          </a:p>
+        </p:txBody>
+      </p:sp>
+      <p:sp>
+        <p:nvSpPr>
+          <p:cNvPr id="44" name="Shape 36"/>
+          <p:cNvSpPr/>
+          <p:nvPr/>
+        </p:nvSpPr>
+        <p:spPr>
+          <a:xfrm>
+            <a:off x="6172200" y="2606040"/>
+            <a:ext cx="3108960" cy="566928"/>
+          </a:xfrm>
+          <a:prstGeom prst="roundRect">
+            <a:avLst>
+              <a:gd name="adj" fmla="val 11290"/>
+            </a:avLst>
+          </a:prstGeom>
+          <a:solidFill>
+            <a:srgbClr val="FFFFFF"/>
+          </a:solidFill>
+          <a:ln w="12700">
+            <a:solidFill>
+              <a:srgbClr val="E0E5EA"/>
+            </a:solidFill>
+            <a:prstDash val="solid"/>
+          </a:ln>
+          <a:effectLst>
+            <a:outerShdw sx="100000" sy="100000" kx="0" ky="0" algn="bl" rotWithShape="0" blurRad="76200" dist="25400" dir="5400000">
+              <a:srgbClr val="1A2027">
+                <a:alpha val="10000"/>
+              </a:srgbClr>
+            </a:outerShdw>
+          </a:effectLst>
+        </p:spPr>
+      </p:sp>
+      <p:sp>
+        <p:nvSpPr>
+          <p:cNvPr id="45" name="Shape 37"/>
+          <p:cNvSpPr/>
+          <p:nvPr/>
+        </p:nvSpPr>
+        <p:spPr>
+          <a:xfrm>
+            <a:off x="6281928" y="2706624"/>
+            <a:ext cx="310896" cy="310896"/>
+          </a:xfrm>
+          <a:prstGeom prst="ellipse">
+            <a:avLst/>
+          </a:prstGeom>
+          <a:solidFill>
+            <a:srgbClr val="3C4857"/>
+          </a:solidFill>
+          <a:ln/>
+          <a:effectLst>
+            <a:outerShdw sx="100000" sy="100000" kx="0" ky="0" algn="bl" rotWithShape="0" blurRad="127000" dist="38100" dir="5400000">
+              <a:srgbClr val="1A2027">
+                <a:alpha val="22000"/>
+              </a:srgbClr>
+            </a:outerShdw>
+          </a:effectLst>
+        </p:spPr>
+      </p:sp>
+      <p:pic>
+        <p:nvPicPr>
+          <p:cNvPr id="46" name="Image 6" descr="preencoded.png">    </p:cNvPr>
+          <p:cNvPicPr>
+            <a:picLocks noChangeAspect="1"/>
+          </p:cNvPicPr>
+          <p:nvPr/>
+        </p:nvPicPr>
+        <p:blipFill>
+          <a:blip r:embed="rId7"/>
+          <a:stretch>
+            <a:fillRect/>
+          </a:stretch>
+        </p:blipFill>
+        <p:spPr>
+          <a:xfrm>
+            <a:off x="6356543" y="2781239"/>
+            <a:ext cx="161666" cy="161666"/>
+          </a:xfrm>
+          <a:prstGeom prst="rect">
+            <a:avLst/>
+          </a:prstGeom>
+        </p:spPr>
+      </p:pic>
+      <p:sp>
+        <p:nvSpPr>
+          <p:cNvPr id="47" name="Text 38"/>
+          <p:cNvSpPr/>
+          <p:nvPr/>
+        </p:nvSpPr>
+        <p:spPr>
+          <a:xfrm>
+            <a:off x="6684264" y="2660904"/>
+            <a:ext cx="2505456" cy="292608"/>
+          </a:xfrm>
+          <a:prstGeom prst="rect">
+            <a:avLst/>
+          </a:prstGeom>
+          <a:noFill/>
+          <a:ln/>
+        </p:spPr>
+        <p:txBody>
+          <a:bodyPr wrap="square" lIns="0" tIns="0" rIns="0" bIns="0" rtlCol="0" anchor="ctr"/>
+          <a:lstStyle/>
+          <a:p>
+            <a:pPr indent="0" marL="0">
+              <a:buNone/>
+            </a:pPr>
+            <a:r>
+              <a:rPr lang="en-US" sz="1050" b="1" dirty="0">
+                <a:solidFill>
+                  <a:srgbClr val="212933"/>
+                </a:solidFill>
+                <a:latin typeface="Calibri" pitchFamily="34" charset="0"/>
+                <a:ea typeface="Calibri" pitchFamily="34" charset="-122"/>
+                <a:cs typeface="Calibri" pitchFamily="34" charset="-120"/>
+              </a:rPr>
+              <a:t>Caddy gateway</a:t>
+            </a:r>
+            <a:endParaRPr lang="en-US" sz="1050" dirty="0"/>
+          </a:p>
+        </p:txBody>
+      </p:sp>
+      <p:sp>
+        <p:nvSpPr>
+          <p:cNvPr id="48" name="Text 39"/>
+          <p:cNvSpPr/>
+          <p:nvPr/>
+        </p:nvSpPr>
+        <p:spPr>
+          <a:xfrm>
+            <a:off x="6300216" y="3008376"/>
+            <a:ext cx="2871216" cy="128016"/>
+          </a:xfrm>
+          <a:prstGeom prst="rect">
+            <a:avLst/>
+          </a:prstGeom>
+          <a:noFill/>
+          <a:ln/>
+        </p:spPr>
+        <p:txBody>
+          <a:bodyPr wrap="square" lIns="0" tIns="0" rIns="0" bIns="0" rtlCol="0" anchor="ctr"/>
+          <a:lstStyle/>
+          <a:p>
+            <a:pPr indent="0" marL="0">
+              <a:lnSpc>
+                <a:spcPct val="98000"/>
+              </a:lnSpc>
+              <a:buNone/>
+            </a:pPr>
+            <a:r>
+              <a:rPr lang="en-US" sz="850" dirty="0">
+                <a:solidFill>
+                  <a:srgbClr val="5C6B7A"/>
+                </a:solidFill>
+                <a:latin typeface="Calibri" pitchFamily="34" charset="0"/>
+                <a:ea typeface="Calibri" pitchFamily="34" charset="-122"/>
+                <a:cs typeface="Calibri" pitchFamily="34" charset="-120"/>
+              </a:rPr>
+              <a:t>reverse proxy · multi-app path routing</a:t>
+            </a:r>
+            <a:endParaRPr lang="en-US" sz="850" dirty="0"/>
+          </a:p>
+        </p:txBody>
+      </p:sp>
+      <p:sp>
+        <p:nvSpPr>
+          <p:cNvPr id="49" name="Shape 40"/>
+          <p:cNvSpPr/>
+          <p:nvPr/>
+        </p:nvSpPr>
+        <p:spPr>
+          <a:xfrm>
+            <a:off x="6172200" y="3291840"/>
+            <a:ext cx="3108960" cy="731520"/>
+          </a:xfrm>
+          <a:prstGeom prst="roundRect">
+            <a:avLst>
+              <a:gd name="adj" fmla="val 8750"/>
+            </a:avLst>
+          </a:prstGeom>
+          <a:solidFill>
+            <a:srgbClr val="FFFFFF"/>
+          </a:solidFill>
+          <a:ln w="12700">
+            <a:solidFill>
+              <a:srgbClr val="E0E5EA"/>
+            </a:solidFill>
+            <a:prstDash val="solid"/>
+          </a:ln>
+          <a:effectLst>
+            <a:outerShdw sx="100000" sy="100000" kx="0" ky="0" algn="bl" rotWithShape="0" blurRad="76200" dist="25400" dir="5400000">
+              <a:srgbClr val="1A2027">
+                <a:alpha val="10000"/>
+              </a:srgbClr>
+            </a:outerShdw>
+          </a:effectLst>
+        </p:spPr>
+      </p:sp>
+      <p:sp>
+        <p:nvSpPr>
+          <p:cNvPr id="50" name="Shape 41"/>
+          <p:cNvSpPr/>
+          <p:nvPr/>
+        </p:nvSpPr>
+        <p:spPr>
+          <a:xfrm>
+            <a:off x="6281928" y="3392424"/>
+            <a:ext cx="310896" cy="310896"/>
+          </a:xfrm>
+          <a:prstGeom prst="ellipse">
+            <a:avLst/>
+          </a:prstGeom>
+          <a:solidFill>
+            <a:srgbClr val="222B36"/>
+          </a:solidFill>
+          <a:ln/>
+          <a:effectLst>
+            <a:outerShdw sx="100000" sy="100000" kx="0" ky="0" algn="bl" rotWithShape="0" blurRad="127000" dist="38100" dir="5400000">
+              <a:srgbClr val="1A2027">
+                <a:alpha val="22000"/>
+              </a:srgbClr>
+            </a:outerShdw>
+          </a:effectLst>
+        </p:spPr>
+      </p:sp>
+      <p:pic>
+        <p:nvPicPr>
+          <p:cNvPr id="51" name="Image 7" descr="preencoded.png">    </p:cNvPr>
+          <p:cNvPicPr>
+            <a:picLocks noChangeAspect="1"/>
+          </p:cNvPicPr>
+          <p:nvPr/>
+        </p:nvPicPr>
+        <p:blipFill>
+          <a:blip r:embed="rId8"/>
+          <a:stretch>
+            <a:fillRect/>
+          </a:stretch>
+        </p:blipFill>
+        <p:spPr>
+          <a:xfrm>
+            <a:off x="6356543" y="3467039"/>
+            <a:ext cx="161666" cy="161666"/>
+          </a:xfrm>
+          <a:prstGeom prst="rect">
+            <a:avLst/>
+          </a:prstGeom>
+        </p:spPr>
+      </p:pic>
+      <p:sp>
+        <p:nvSpPr>
+          <p:cNvPr id="52" name="Text 42"/>
+          <p:cNvSpPr/>
+          <p:nvPr/>
+        </p:nvSpPr>
+        <p:spPr>
+          <a:xfrm>
+            <a:off x="6684264" y="3346704"/>
+            <a:ext cx="2505456" cy="292608"/>
+          </a:xfrm>
+          <a:prstGeom prst="rect">
+            <a:avLst/>
+          </a:prstGeom>
+          <a:noFill/>
+          <a:ln/>
+        </p:spPr>
+        <p:txBody>
+          <a:bodyPr wrap="square" lIns="0" tIns="0" rIns="0" bIns="0" rtlCol="0" anchor="ctr"/>
+          <a:lstStyle/>
+          <a:p>
+            <a:pPr indent="0" marL="0">
+              <a:buNone/>
+            </a:pPr>
+            <a:r>
+              <a:rPr lang="en-US" sz="1050" b="1" dirty="0">
+                <a:solidFill>
+                  <a:srgbClr val="212933"/>
+                </a:solidFill>
+                <a:latin typeface="Calibri" pitchFamily="34" charset="0"/>
+                <a:ea typeface="Calibri" pitchFamily="34" charset="-122"/>
+                <a:cs typeface="Calibri" pitchFamily="34" charset="-120"/>
+              </a:rPr>
+              <a:t>Node / Express API (TypeScript)</a:t>
+            </a:r>
+            <a:endParaRPr lang="en-US" sz="1050" dirty="0"/>
+          </a:p>
+        </p:txBody>
+      </p:sp>
+      <p:sp>
+        <p:nvSpPr>
+          <p:cNvPr id="53" name="Text 43"/>
+          <p:cNvSpPr/>
+          <p:nvPr/>
+        </p:nvSpPr>
+        <p:spPr>
+          <a:xfrm>
+            <a:off x="6300216" y="3694176"/>
+            <a:ext cx="2871216" cy="292608"/>
+          </a:xfrm>
+          <a:prstGeom prst="rect">
+            <a:avLst/>
+          </a:prstGeom>
+          <a:noFill/>
+          <a:ln/>
+        </p:spPr>
+        <p:txBody>
+          <a:bodyPr wrap="square" lIns="0" tIns="0" rIns="0" bIns="0" rtlCol="0" anchor="ctr"/>
+          <a:lstStyle/>
+          <a:p>
+            <a:pPr indent="0" marL="0">
+              <a:lnSpc>
+                <a:spcPct val="98000"/>
+              </a:lnSpc>
+              <a:buNone/>
+            </a:pPr>
+            <a:r>
+              <a:rPr lang="en-US" sz="850" dirty="0">
+                <a:solidFill>
+                  <a:srgbClr val="5C6B7A"/>
+                </a:solidFill>
+                <a:latin typeface="Calibri" pitchFamily="34" charset="0"/>
+                <a:ea typeface="Calibri" pitchFamily="34" charset="-122"/>
+                <a:cs typeface="Calibri" pitchFamily="34" charset="-120"/>
+              </a:rPr>
+              <a:t>REST /api · SSE streams out · WS media receiver · systemd-managed</a:t>
+            </a:r>
+            <a:endParaRPr lang="en-US" sz="850" dirty="0"/>
+          </a:p>
+        </p:txBody>
+      </p:sp>
+      <p:sp>
+        <p:nvSpPr>
+          <p:cNvPr id="54" name="Shape 44"/>
+          <p:cNvSpPr/>
+          <p:nvPr/>
+        </p:nvSpPr>
+        <p:spPr>
+          <a:xfrm>
+            <a:off x="6172200" y="4160520"/>
+            <a:ext cx="3108960" cy="658368"/>
+          </a:xfrm>
+          <a:prstGeom prst="roundRect">
+            <a:avLst>
+              <a:gd name="adj" fmla="val 9722"/>
+            </a:avLst>
+          </a:prstGeom>
+          <a:solidFill>
+            <a:srgbClr val="FFFFFF"/>
+          </a:solidFill>
+          <a:ln w="12700">
+            <a:solidFill>
+              <a:srgbClr val="E0E5EA"/>
+            </a:solidFill>
+            <a:prstDash val="solid"/>
+          </a:ln>
+          <a:effectLst>
+            <a:outerShdw sx="100000" sy="100000" kx="0" ky="0" algn="bl" rotWithShape="0" blurRad="76200" dist="25400" dir="5400000">
+              <a:srgbClr val="1A2027">
+                <a:alpha val="10000"/>
+              </a:srgbClr>
+            </a:outerShdw>
+          </a:effectLst>
+        </p:spPr>
+      </p:sp>
+      <p:sp>
+        <p:nvSpPr>
+          <p:cNvPr id="55" name="Shape 45"/>
+          <p:cNvSpPr/>
+          <p:nvPr/>
+        </p:nvSpPr>
+        <p:spPr>
+          <a:xfrm>
+            <a:off x="6281928" y="4261104"/>
+            <a:ext cx="310896" cy="310896"/>
+          </a:xfrm>
+          <a:prstGeom prst="ellipse">
+            <a:avLst/>
+          </a:prstGeom>
+          <a:solidFill>
+            <a:srgbClr val="E8590C"/>
+          </a:solidFill>
+          <a:ln/>
+          <a:effectLst>
+            <a:outerShdw sx="100000" sy="100000" kx="0" ky="0" algn="bl" rotWithShape="0" blurRad="127000" dist="38100" dir="5400000">
+              <a:srgbClr val="1A2027">
+                <a:alpha val="22000"/>
+              </a:srgbClr>
+            </a:outerShdw>
+          </a:effectLst>
+        </p:spPr>
+      </p:sp>
+      <p:pic>
+        <p:nvPicPr>
+          <p:cNvPr id="56" name="Image 8" descr="preencoded.png">    </p:cNvPr>
+          <p:cNvPicPr>
+            <a:picLocks noChangeAspect="1"/>
+          </p:cNvPicPr>
+          <p:nvPr/>
+        </p:nvPicPr>
+        <p:blipFill>
+          <a:blip r:embed="rId9"/>
+          <a:stretch>
+            <a:fillRect/>
+          </a:stretch>
+        </p:blipFill>
+        <p:spPr>
+          <a:xfrm>
+            <a:off x="6356543" y="4335719"/>
+            <a:ext cx="161666" cy="161666"/>
+          </a:xfrm>
+          <a:prstGeom prst="rect">
+            <a:avLst/>
+          </a:prstGeom>
+        </p:spPr>
+      </p:pic>
+      <p:sp>
+        <p:nvSpPr>
+          <p:cNvPr id="57" name="Text 46"/>
+          <p:cNvSpPr/>
+          <p:nvPr/>
+        </p:nvSpPr>
+        <p:spPr>
+          <a:xfrm>
+            <a:off x="6684264" y="4215384"/>
+            <a:ext cx="2505456" cy="292608"/>
+          </a:xfrm>
+          <a:prstGeom prst="rect">
+            <a:avLst/>
+          </a:prstGeom>
+          <a:noFill/>
+          <a:ln/>
+        </p:spPr>
+        <p:txBody>
+          <a:bodyPr wrap="square" lIns="0" tIns="0" rIns="0" bIns="0" rtlCol="0" anchor="ctr"/>
+          <a:lstStyle/>
+          <a:p>
+            <a:pPr indent="0" marL="0">
+              <a:buNone/>
+            </a:pPr>
+            <a:r>
+              <a:rPr lang="en-US" sz="1050" b="1" dirty="0">
+                <a:solidFill>
+                  <a:srgbClr val="212933"/>
+                </a:solidFill>
+                <a:latin typeface="Calibri" pitchFamily="34" charset="0"/>
+                <a:ea typeface="Calibri" pitchFamily="34" charset="-122"/>
+                <a:cs typeface="Calibri" pitchFamily="34" charset="-120"/>
+              </a:rPr>
+              <a:t>Agentic AI layer</a:t>
+            </a:r>
+            <a:endParaRPr lang="en-US" sz="1050" dirty="0"/>
+          </a:p>
+        </p:txBody>
+      </p:sp>
+      <p:sp>
+        <p:nvSpPr>
+          <p:cNvPr id="58" name="Text 47"/>
+          <p:cNvSpPr/>
+          <p:nvPr/>
+        </p:nvSpPr>
+        <p:spPr>
+          <a:xfrm>
+            <a:off x="6300216" y="4562856"/>
+            <a:ext cx="2871216" cy="219456"/>
+          </a:xfrm>
+          <a:prstGeom prst="rect">
+            <a:avLst/>
+          </a:prstGeom>
+          <a:noFill/>
+          <a:ln/>
+        </p:spPr>
+        <p:txBody>
+          <a:bodyPr wrap="square" lIns="0" tIns="0" rIns="0" bIns="0" rtlCol="0" anchor="ctr"/>
+          <a:lstStyle/>
+          <a:p>
+            <a:pPr indent="0" marL="0">
+              <a:lnSpc>
+                <a:spcPct val="98000"/>
+              </a:lnSpc>
+              <a:buNone/>
+            </a:pPr>
+            <a:r>
+              <a:rPr lang="en-US" sz="850" dirty="0">
+                <a:solidFill>
+                  <a:srgbClr val="5C6B7A"/>
+                </a:solidFill>
+                <a:latin typeface="Calibri" pitchFamily="34" charset="0"/>
+                <a:ea typeface="Calibri" pitchFamily="34" charset="-122"/>
+                <a:cs typeface="Calibri" pitchFamily="34" charset="-120"/>
+              </a:rPr>
+              <a:t>Atlas (LangGraph, 19 tools) · QA evaluator · hybrid RAG retriever (BM25 + vector, RRF-fused) · prompt cache</a:t>
+            </a:r>
+            <a:endParaRPr lang="en-US" sz="850" dirty="0"/>
+          </a:p>
+        </p:txBody>
+      </p:sp>
+      <p:sp>
+        <p:nvSpPr>
+          <p:cNvPr id="59" name="Shape 48"/>
+          <p:cNvSpPr/>
+          <p:nvPr/>
+        </p:nvSpPr>
+        <p:spPr>
+          <a:xfrm>
+            <a:off x="6172200" y="4956048"/>
+            <a:ext cx="3108960" cy="658368"/>
+          </a:xfrm>
+          <a:prstGeom prst="roundRect">
+            <a:avLst>
+              <a:gd name="adj" fmla="val 9722"/>
+            </a:avLst>
+          </a:prstGeom>
+          <a:solidFill>
+            <a:srgbClr val="FFFFFF"/>
+          </a:solidFill>
+          <a:ln w="12700">
+            <a:solidFill>
+              <a:srgbClr val="E0E5EA"/>
+            </a:solidFill>
+            <a:prstDash val="solid"/>
+          </a:ln>
+          <a:effectLst>
+            <a:outerShdw sx="100000" sy="100000" kx="0" ky="0" algn="bl" rotWithShape="0" blurRad="76200" dist="25400" dir="5400000">
+              <a:srgbClr val="1A2027">
+                <a:alpha val="10000"/>
+              </a:srgbClr>
+            </a:outerShdw>
+          </a:effectLst>
+        </p:spPr>
+      </p:sp>
+      <p:sp>
+        <p:nvSpPr>
+          <p:cNvPr id="60" name="Shape 49"/>
+          <p:cNvSpPr/>
+          <p:nvPr/>
+        </p:nvSpPr>
+        <p:spPr>
+          <a:xfrm>
+            <a:off x="6281928" y="5056632"/>
+            <a:ext cx="310896" cy="310896"/>
+          </a:xfrm>
+          <a:prstGeom prst="ellipse">
+            <a:avLst/>
+          </a:prstGeom>
+          <a:solidFill>
+            <a:srgbClr val="50708C"/>
+          </a:solidFill>
+          <a:ln/>
+          <a:effectLst>
+            <a:outerShdw sx="100000" sy="100000" kx="0" ky="0" algn="bl" rotWithShape="0" blurRad="127000" dist="38100" dir="5400000">
+              <a:srgbClr val="1A2027">
+                <a:alpha val="22000"/>
+              </a:srgbClr>
+            </a:outerShdw>
+          </a:effectLst>
+        </p:spPr>
+      </p:sp>
+      <p:pic>
+        <p:nvPicPr>
+          <p:cNvPr id="61" name="Image 9" descr="preencoded.png">    </p:cNvPr>
+          <p:cNvPicPr>
+            <a:picLocks noChangeAspect="1"/>
+          </p:cNvPicPr>
+          <p:nvPr/>
+        </p:nvPicPr>
+        <p:blipFill>
+          <a:blip r:embed="rId10"/>
+          <a:stretch>
+            <a:fillRect/>
+          </a:stretch>
+        </p:blipFill>
+        <p:spPr>
+          <a:xfrm>
+            <a:off x="6356543" y="5131247"/>
+            <a:ext cx="161666" cy="161666"/>
+          </a:xfrm>
+          <a:prstGeom prst="rect">
+            <a:avLst/>
+          </a:prstGeom>
+        </p:spPr>
+      </p:pic>
+      <p:sp>
+        <p:nvSpPr>
+          <p:cNvPr id="62" name="Text 50"/>
+          <p:cNvSpPr/>
+          <p:nvPr/>
+        </p:nvSpPr>
+        <p:spPr>
+          <a:xfrm>
+            <a:off x="6684264" y="5010912"/>
+            <a:ext cx="2505456" cy="292608"/>
+          </a:xfrm>
+          <a:prstGeom prst="rect">
+            <a:avLst/>
+          </a:prstGeom>
+          <a:noFill/>
+          <a:ln/>
+        </p:spPr>
+        <p:txBody>
+          <a:bodyPr wrap="square" lIns="0" tIns="0" rIns="0" bIns="0" rtlCol="0" anchor="ctr"/>
+          <a:lstStyle/>
+          <a:p>
+            <a:pPr indent="0" marL="0">
+              <a:buNone/>
+            </a:pPr>
+            <a:r>
+              <a:rPr lang="en-US" sz="1050" b="1" dirty="0">
+                <a:solidFill>
+                  <a:srgbClr val="212933"/>
+                </a:solidFill>
+                <a:latin typeface="Calibri" pitchFamily="34" charset="0"/>
+                <a:ea typeface="Calibri" pitchFamily="34" charset="-122"/>
+                <a:cs typeface="Calibri" pitchFamily="34" charset="-120"/>
+              </a:rPr>
+              <a:t>Real-time analysis</a:t>
+            </a:r>
+            <a:endParaRPr lang="en-US" sz="1050" dirty="0"/>
+          </a:p>
+        </p:txBody>
+      </p:sp>
+      <p:sp>
+        <p:nvSpPr>
+          <p:cNvPr id="63" name="Text 51"/>
+          <p:cNvSpPr/>
+          <p:nvPr/>
+        </p:nvSpPr>
+        <p:spPr>
+          <a:xfrm>
+            <a:off x="6300216" y="5358384"/>
+            <a:ext cx="2871216" cy="219456"/>
+          </a:xfrm>
+          <a:prstGeom prst="rect">
+            <a:avLst/>
+          </a:prstGeom>
+          <a:noFill/>
+          <a:ln/>
+        </p:spPr>
+        <p:txBody>
+          <a:bodyPr wrap="square" lIns="0" tIns="0" rIns="0" bIns="0" rtlCol="0" anchor="ctr"/>
+          <a:lstStyle/>
+          <a:p>
+            <a:pPr indent="0" marL="0">
+              <a:lnSpc>
+                <a:spcPct val="98000"/>
+              </a:lnSpc>
+              <a:buNone/>
+            </a:pPr>
+            <a:r>
+              <a:rPr lang="en-US" sz="850" dirty="0">
+                <a:solidFill>
+                  <a:srgbClr val="5C6B7A"/>
+                </a:solidFill>
+                <a:latin typeface="Calibri" pitchFamily="34" charset="0"/>
+                <a:ea typeface="Calibri" pitchFamily="34" charset="-122"/>
+                <a:cs typeface="Calibri" pitchFamily="34" charset="-120"/>
+              </a:rPr>
+              <a:t>in-memory call bus · compliance rules · entities · emotion · coaching</a:t>
+            </a:r>
+            <a:endParaRPr lang="en-US" sz="850" dirty="0"/>
+          </a:p>
+        </p:txBody>
+      </p:sp>
+      <p:sp>
+        <p:nvSpPr>
+          <p:cNvPr id="64" name="Shape 52"/>
+          <p:cNvSpPr/>
+          <p:nvPr/>
+        </p:nvSpPr>
+        <p:spPr>
+          <a:xfrm>
+            <a:off x="7726680" y="2487168"/>
+            <a:ext cx="0" cy="118872"/>
+          </a:xfrm>
+          <a:prstGeom prst="line">
+            <a:avLst/>
+          </a:prstGeom>
+          <a:noFill/>
+          <a:ln w="19050">
+            <a:solidFill>
+              <a:srgbClr val="8A9AA8"/>
+            </a:solidFill>
+            <a:prstDash val="solid"/>
+            <a:tailEnd type="triangle"/>
+          </a:ln>
+        </p:spPr>
+      </p:sp>
+      <p:sp>
+        <p:nvSpPr>
+          <p:cNvPr id="65" name="Shape 53"/>
+          <p:cNvSpPr/>
+          <p:nvPr/>
+        </p:nvSpPr>
+        <p:spPr>
+          <a:xfrm>
+            <a:off x="7726680" y="3172968"/>
+            <a:ext cx="0" cy="118872"/>
+          </a:xfrm>
+          <a:prstGeom prst="line">
+            <a:avLst/>
+          </a:prstGeom>
+          <a:noFill/>
+          <a:ln w="19050">
+            <a:solidFill>
+              <a:srgbClr val="8A9AA8"/>
+            </a:solidFill>
+            <a:prstDash val="solid"/>
+            <a:tailEnd type="triangle"/>
+          </a:ln>
+        </p:spPr>
+      </p:sp>
+      <p:sp>
+        <p:nvSpPr>
+          <p:cNvPr id="66" name="Shape 54"/>
+          <p:cNvSpPr/>
+          <p:nvPr/>
+        </p:nvSpPr>
+        <p:spPr>
+          <a:xfrm>
+            <a:off x="7726680" y="4023360"/>
+            <a:ext cx="0" cy="137160"/>
+          </a:xfrm>
+          <a:prstGeom prst="line">
+            <a:avLst/>
+          </a:prstGeom>
+          <a:noFill/>
+          <a:ln w="19050">
+            <a:solidFill>
+              <a:srgbClr val="8A9AA8"/>
+            </a:solidFill>
+            <a:prstDash val="solid"/>
+            <a:tailEnd type="triangle"/>
+          </a:ln>
+        </p:spPr>
+      </p:sp>
+      <p:sp>
+        <p:nvSpPr>
+          <p:cNvPr id="67" name="Shape 55"/>
+          <p:cNvSpPr/>
+          <p:nvPr/>
+        </p:nvSpPr>
+        <p:spPr>
+          <a:xfrm>
+            <a:off x="7726680" y="4818888"/>
+            <a:ext cx="0" cy="137160"/>
+          </a:xfrm>
+          <a:prstGeom prst="line">
+            <a:avLst/>
+          </a:prstGeom>
+          <a:noFill/>
+          <a:ln w="19050">
+            <a:solidFill>
+              <a:srgbClr val="8A9AA8"/>
+            </a:solidFill>
+            <a:prstDash val="solid"/>
+            <a:tailEnd type="triangle"/>
+          </a:ln>
+        </p:spPr>
+      </p:sp>
+      <p:sp>
+        <p:nvSpPr>
+          <p:cNvPr id="68" name="Shape 56"/>
+          <p:cNvSpPr/>
+          <p:nvPr/>
+        </p:nvSpPr>
+        <p:spPr>
+          <a:xfrm>
+            <a:off x="10012680" y="1938528"/>
+            <a:ext cx="1554480" cy="731520"/>
+          </a:xfrm>
+          <a:prstGeom prst="roundRect">
+            <a:avLst>
+              <a:gd name="adj" fmla="val 8750"/>
+            </a:avLst>
+          </a:prstGeom>
+          <a:solidFill>
+            <a:srgbClr val="FFFFFF"/>
+          </a:solidFill>
+          <a:ln w="12700">
+            <a:solidFill>
+              <a:srgbClr val="E0E5EA"/>
+            </a:solidFill>
+            <a:prstDash val="solid"/>
+          </a:ln>
+          <a:effectLst>
+            <a:outerShdw sx="100000" sy="100000" kx="0" ky="0" algn="bl" rotWithShape="0" blurRad="76200" dist="25400" dir="5400000">
+              <a:srgbClr val="1A2027">
+                <a:alpha val="10000"/>
+              </a:srgbClr>
+            </a:outerShdw>
+          </a:effectLst>
+        </p:spPr>
+      </p:sp>
+      <p:sp>
+        <p:nvSpPr>
+          <p:cNvPr id="69" name="Shape 57"/>
+          <p:cNvSpPr/>
+          <p:nvPr/>
+        </p:nvSpPr>
+        <p:spPr>
+          <a:xfrm>
+            <a:off x="10122408" y="2011680"/>
+            <a:ext cx="256032" cy="256032"/>
+          </a:xfrm>
+          <a:prstGeom prst="ellipse">
+            <a:avLst/>
+          </a:prstGeom>
+          <a:solidFill>
+            <a:srgbClr val="50708C"/>
+          </a:solidFill>
+          <a:ln/>
+          <a:effectLst>
+            <a:outerShdw sx="100000" sy="100000" kx="0" ky="0" algn="bl" rotWithShape="0" blurRad="127000" dist="38100" dir="5400000">
+              <a:srgbClr val="1A2027">
+                <a:alpha val="22000"/>
+              </a:srgbClr>
+            </a:outerShdw>
+          </a:effectLst>
+        </p:spPr>
+      </p:sp>
+      <p:pic>
+        <p:nvPicPr>
+          <p:cNvPr id="70" name="Image 10" descr="preencoded.png">    </p:cNvPr>
+          <p:cNvPicPr>
+            <a:picLocks noChangeAspect="1"/>
+          </p:cNvPicPr>
+          <p:nvPr/>
+        </p:nvPicPr>
+        <p:blipFill>
+          <a:blip r:embed="rId11"/>
+          <a:stretch>
+            <a:fillRect/>
+          </a:stretch>
+        </p:blipFill>
+        <p:spPr>
+          <a:xfrm>
+            <a:off x="10183856" y="2073128"/>
+            <a:ext cx="133137" cy="133137"/>
+          </a:xfrm>
+          <a:prstGeom prst="rect">
+            <a:avLst/>
+          </a:prstGeom>
+        </p:spPr>
+      </p:pic>
+      <p:sp>
+        <p:nvSpPr>
+          <p:cNvPr id="71" name="Text 58"/>
+          <p:cNvSpPr/>
+          <p:nvPr/>
+        </p:nvSpPr>
+        <p:spPr>
+          <a:xfrm>
+            <a:off x="10469880" y="1975104"/>
+            <a:ext cx="1005840" cy="274320"/>
+          </a:xfrm>
+          <a:prstGeom prst="rect">
+            <a:avLst/>
+          </a:prstGeom>
+          <a:noFill/>
+          <a:ln/>
+        </p:spPr>
+        <p:txBody>
+          <a:bodyPr wrap="square" lIns="0" tIns="0" rIns="0" bIns="0" rtlCol="0" anchor="ctr"/>
+          <a:lstStyle/>
+          <a:p>
+            <a:pPr indent="0" marL="0">
+              <a:buNone/>
+            </a:pPr>
+            <a:r>
+              <a:rPr lang="en-US" sz="950" b="1" dirty="0">
+                <a:solidFill>
+                  <a:srgbClr val="212933"/>
+                </a:solidFill>
+                <a:latin typeface="Calibri" pitchFamily="34" charset="0"/>
+                <a:ea typeface="Calibri" pitchFamily="34" charset="-122"/>
+                <a:cs typeface="Calibri" pitchFamily="34" charset="-120"/>
+              </a:rPr>
+              <a:t>Deepgram</a:t>
+            </a:r>
+            <a:endParaRPr lang="en-US" sz="950" dirty="0"/>
+          </a:p>
+        </p:txBody>
+      </p:sp>
+      <p:sp>
+        <p:nvSpPr>
+          <p:cNvPr id="72" name="Text 59"/>
+          <p:cNvSpPr/>
+          <p:nvPr/>
+        </p:nvSpPr>
+        <p:spPr>
+          <a:xfrm>
+            <a:off x="10140696" y="2249424"/>
+            <a:ext cx="1316736" cy="402336"/>
+          </a:xfrm>
+          <a:prstGeom prst="rect">
+            <a:avLst/>
+          </a:prstGeom>
+          <a:noFill/>
+          <a:ln/>
+        </p:spPr>
+        <p:txBody>
+          <a:bodyPr wrap="square" lIns="0" tIns="0" rIns="0" bIns="0" rtlCol="0" anchor="ctr"/>
+          <a:lstStyle/>
+          <a:p>
+            <a:pPr indent="0" marL="0">
+              <a:lnSpc>
+                <a:spcPct val="98000"/>
+              </a:lnSpc>
+              <a:buNone/>
+            </a:pPr>
+            <a:r>
+              <a:rPr lang="en-US" sz="750" dirty="0">
+                <a:solidFill>
+                  <a:srgbClr val="5C6B7A"/>
+                </a:solidFill>
+                <a:latin typeface="Calibri" pitchFamily="34" charset="0"/>
+                <a:ea typeface="Calibri" pitchFamily="34" charset="-122"/>
+                <a:cs typeface="Calibri" pitchFamily="34" charset="-120"/>
+              </a:rPr>
+              <a:t>streaming STT — both call tracks</a:t>
+            </a:r>
+            <a:endParaRPr lang="en-US" sz="750" dirty="0"/>
+          </a:p>
+        </p:txBody>
+      </p:sp>
+      <p:sp>
+        <p:nvSpPr>
+          <p:cNvPr id="73" name="Shape 60"/>
+          <p:cNvSpPr/>
+          <p:nvPr/>
+        </p:nvSpPr>
+        <p:spPr>
+          <a:xfrm>
+            <a:off x="10012680" y="2761488"/>
+            <a:ext cx="1554480" cy="685800"/>
+          </a:xfrm>
+          <a:prstGeom prst="roundRect">
+            <a:avLst>
+              <a:gd name="adj" fmla="val 9333"/>
+            </a:avLst>
+          </a:prstGeom>
+          <a:solidFill>
+            <a:srgbClr val="FFFFFF"/>
+          </a:solidFill>
+          <a:ln w="12700">
+            <a:solidFill>
+              <a:srgbClr val="E0E5EA"/>
+            </a:solidFill>
+            <a:prstDash val="solid"/>
+          </a:ln>
+          <a:effectLst>
+            <a:outerShdw sx="100000" sy="100000" kx="0" ky="0" algn="bl" rotWithShape="0" blurRad="76200" dist="25400" dir="5400000">
+              <a:srgbClr val="1A2027">
+                <a:alpha val="10000"/>
+              </a:srgbClr>
+            </a:outerShdw>
+          </a:effectLst>
+        </p:spPr>
+      </p:sp>
+      <p:sp>
+        <p:nvSpPr>
+          <p:cNvPr id="74" name="Shape 61"/>
+          <p:cNvSpPr/>
+          <p:nvPr/>
+        </p:nvSpPr>
+        <p:spPr>
+          <a:xfrm>
+            <a:off x="10122408" y="2834640"/>
+            <a:ext cx="256032" cy="256032"/>
+          </a:xfrm>
+          <a:prstGeom prst="ellipse">
+            <a:avLst/>
+          </a:prstGeom>
+          <a:solidFill>
+            <a:srgbClr val="C0392B"/>
+          </a:solidFill>
+          <a:ln/>
+          <a:effectLst>
+            <a:outerShdw sx="100000" sy="100000" kx="0" ky="0" algn="bl" rotWithShape="0" blurRad="127000" dist="38100" dir="5400000">
+              <a:srgbClr val="1A2027">
+                <a:alpha val="22000"/>
+              </a:srgbClr>
+            </a:outerShdw>
+          </a:effectLst>
+        </p:spPr>
+      </p:sp>
+      <p:pic>
+        <p:nvPicPr>
+          <p:cNvPr id="75" name="Image 11" descr="preencoded.png">    </p:cNvPr>
+          <p:cNvPicPr>
+            <a:picLocks noChangeAspect="1"/>
+          </p:cNvPicPr>
+          <p:nvPr/>
+        </p:nvPicPr>
+        <p:blipFill>
+          <a:blip r:embed="rId12"/>
+          <a:stretch>
+            <a:fillRect/>
+          </a:stretch>
+        </p:blipFill>
+        <p:spPr>
+          <a:xfrm>
+            <a:off x="10183856" y="2896088"/>
+            <a:ext cx="133137" cy="133137"/>
+          </a:xfrm>
+          <a:prstGeom prst="rect">
+            <a:avLst/>
+          </a:prstGeom>
+        </p:spPr>
+      </p:pic>
+      <p:sp>
+        <p:nvSpPr>
+          <p:cNvPr id="76" name="Text 62"/>
+          <p:cNvSpPr/>
+          <p:nvPr/>
+        </p:nvSpPr>
+        <p:spPr>
+          <a:xfrm>
+            <a:off x="10469880" y="2798064"/>
+            <a:ext cx="1005840" cy="274320"/>
+          </a:xfrm>
+          <a:prstGeom prst="rect">
+            <a:avLst/>
+          </a:prstGeom>
+          <a:noFill/>
+          <a:ln/>
+        </p:spPr>
+        <p:txBody>
+          <a:bodyPr wrap="square" lIns="0" tIns="0" rIns="0" bIns="0" rtlCol="0" anchor="ctr"/>
+          <a:lstStyle/>
+          <a:p>
+            <a:pPr indent="0" marL="0">
+              <a:buNone/>
+            </a:pPr>
+            <a:r>
+              <a:rPr lang="en-US" sz="950" b="1" dirty="0">
+                <a:solidFill>
+                  <a:srgbClr val="212933"/>
+                </a:solidFill>
+                <a:latin typeface="Calibri" pitchFamily="34" charset="0"/>
+                <a:ea typeface="Calibri" pitchFamily="34" charset="-122"/>
+                <a:cs typeface="Calibri" pitchFamily="34" charset="-120"/>
+              </a:rPr>
+              <a:t>OpenRouter</a:t>
+            </a:r>
+            <a:endParaRPr lang="en-US" sz="950" dirty="0"/>
+          </a:p>
+        </p:txBody>
+      </p:sp>
+      <p:sp>
+        <p:nvSpPr>
+          <p:cNvPr id="77" name="Text 63"/>
+          <p:cNvSpPr/>
+          <p:nvPr/>
+        </p:nvSpPr>
+        <p:spPr>
+          <a:xfrm>
+            <a:off x="10140696" y="3072384"/>
+            <a:ext cx="1316736" cy="356616"/>
+          </a:xfrm>
+          <a:prstGeom prst="rect">
+            <a:avLst/>
+          </a:prstGeom>
+          <a:noFill/>
+          <a:ln/>
+        </p:spPr>
+        <p:txBody>
+          <a:bodyPr wrap="square" lIns="0" tIns="0" rIns="0" bIns="0" rtlCol="0" anchor="ctr"/>
+          <a:lstStyle/>
+          <a:p>
+            <a:pPr indent="0" marL="0">
+              <a:lnSpc>
+                <a:spcPct val="98000"/>
+              </a:lnSpc>
+              <a:buNone/>
+            </a:pPr>
+            <a:r>
+              <a:rPr lang="en-US" sz="750" dirty="0">
+                <a:solidFill>
+                  <a:srgbClr val="5C6B7A"/>
+                </a:solidFill>
+                <a:latin typeface="Calibri" pitchFamily="34" charset="0"/>
+                <a:ea typeface="Calibri" pitchFamily="34" charset="-122"/>
+                <a:cs typeface="Calibri" pitchFamily="34" charset="-120"/>
+              </a:rPr>
+              <a:t>Claude Haiku / Opus — LLM calls</a:t>
+            </a:r>
+            <a:endParaRPr lang="en-US" sz="750" dirty="0"/>
+          </a:p>
+        </p:txBody>
+      </p:sp>
+      <p:sp>
+        <p:nvSpPr>
+          <p:cNvPr id="78" name="Shape 64"/>
+          <p:cNvSpPr/>
+          <p:nvPr/>
+        </p:nvSpPr>
+        <p:spPr>
+          <a:xfrm>
+            <a:off x="10012680" y="4041648"/>
+            <a:ext cx="1554480" cy="530352"/>
+          </a:xfrm>
+          <a:prstGeom prst="roundRect">
+            <a:avLst>
+              <a:gd name="adj" fmla="val 12069"/>
+            </a:avLst>
+          </a:prstGeom>
+          <a:solidFill>
+            <a:srgbClr val="FFFFFF"/>
+          </a:solidFill>
+          <a:ln w="12700">
+            <a:solidFill>
+              <a:srgbClr val="E0E5EA"/>
+            </a:solidFill>
+            <a:prstDash val="solid"/>
+          </a:ln>
+          <a:effectLst>
+            <a:outerShdw sx="100000" sy="100000" kx="0" ky="0" algn="bl" rotWithShape="0" blurRad="76200" dist="25400" dir="5400000">
+              <a:srgbClr val="1A2027">
+                <a:alpha val="10000"/>
+              </a:srgbClr>
+            </a:outerShdw>
+          </a:effectLst>
+        </p:spPr>
+      </p:sp>
+      <p:sp>
+        <p:nvSpPr>
+          <p:cNvPr id="79" name="Shape 65"/>
+          <p:cNvSpPr/>
+          <p:nvPr/>
+        </p:nvSpPr>
+        <p:spPr>
+          <a:xfrm>
+            <a:off x="10122408" y="4114800"/>
+            <a:ext cx="256032" cy="256032"/>
+          </a:xfrm>
+          <a:prstGeom prst="ellipse">
+            <a:avLst/>
+          </a:prstGeom>
+          <a:solidFill>
+            <a:srgbClr val="3C4857"/>
+          </a:solidFill>
+          <a:ln/>
+          <a:effectLst>
+            <a:outerShdw sx="100000" sy="100000" kx="0" ky="0" algn="bl" rotWithShape="0" blurRad="127000" dist="38100" dir="5400000">
+              <a:srgbClr val="1A2027">
+                <a:alpha val="22000"/>
+              </a:srgbClr>
+            </a:outerShdw>
+          </a:effectLst>
+        </p:spPr>
+      </p:sp>
+      <p:pic>
+        <p:nvPicPr>
+          <p:cNvPr id="80" name="Image 12" descr="preencoded.png">    </p:cNvPr>
+          <p:cNvPicPr>
+            <a:picLocks noChangeAspect="1"/>
+          </p:cNvPicPr>
+          <p:nvPr/>
+        </p:nvPicPr>
+        <p:blipFill>
+          <a:blip r:embed="rId13"/>
+          <a:stretch>
+            <a:fillRect/>
+          </a:stretch>
+        </p:blipFill>
+        <p:spPr>
+          <a:xfrm>
+            <a:off x="10183856" y="4176248"/>
+            <a:ext cx="133137" cy="133137"/>
+          </a:xfrm>
+          <a:prstGeom prst="rect">
+            <a:avLst/>
+          </a:prstGeom>
+        </p:spPr>
+      </p:pic>
+      <p:sp>
+        <p:nvSpPr>
+          <p:cNvPr id="81" name="Text 66"/>
+          <p:cNvSpPr/>
+          <p:nvPr/>
+        </p:nvSpPr>
+        <p:spPr>
+          <a:xfrm>
+            <a:off x="10469880" y="4078224"/>
+            <a:ext cx="1005840" cy="274320"/>
+          </a:xfrm>
+          <a:prstGeom prst="rect">
+            <a:avLst/>
+          </a:prstGeom>
+          <a:noFill/>
+          <a:ln/>
+        </p:spPr>
+        <p:txBody>
+          <a:bodyPr wrap="square" lIns="0" tIns="0" rIns="0" bIns="0" rtlCol="0" anchor="ctr"/>
+          <a:lstStyle/>
+          <a:p>
+            <a:pPr indent="0" marL="0">
+              <a:buNone/>
+            </a:pPr>
+            <a:r>
+              <a:rPr lang="en-US" sz="950" b="1" dirty="0">
+                <a:solidFill>
+                  <a:srgbClr val="212933"/>
+                </a:solidFill>
+                <a:latin typeface="Calibri" pitchFamily="34" charset="0"/>
+                <a:ea typeface="Calibri" pitchFamily="34" charset="-122"/>
+                <a:cs typeface="Calibri" pitchFamily="34" charset="-120"/>
+              </a:rPr>
+              <a:t>Ollama embedder</a:t>
+            </a:r>
+            <a:endParaRPr lang="en-US" sz="950" dirty="0"/>
+          </a:p>
+        </p:txBody>
+      </p:sp>
+      <p:sp>
+        <p:nvSpPr>
+          <p:cNvPr id="82" name="Text 67"/>
+          <p:cNvSpPr/>
+          <p:nvPr/>
+        </p:nvSpPr>
+        <p:spPr>
+          <a:xfrm>
+            <a:off x="10140696" y="4352544"/>
+            <a:ext cx="1316736" cy="201168"/>
+          </a:xfrm>
+          <a:prstGeom prst="rect">
+            <a:avLst/>
+          </a:prstGeom>
+          <a:noFill/>
+          <a:ln/>
+        </p:spPr>
+        <p:txBody>
+          <a:bodyPr wrap="square" lIns="0" tIns="0" rIns="0" bIns="0" rtlCol="0" anchor="ctr"/>
+          <a:lstStyle/>
+          <a:p>
+            <a:pPr indent="0" marL="0">
+              <a:lnSpc>
+                <a:spcPct val="98000"/>
+              </a:lnSpc>
+              <a:buNone/>
+            </a:pPr>
+            <a:r>
+              <a:rPr lang="en-US" sz="750" dirty="0">
+                <a:solidFill>
+                  <a:srgbClr val="5C6B7A"/>
+                </a:solidFill>
+                <a:latin typeface="Calibri" pitchFamily="34" charset="0"/>
+                <a:ea typeface="Calibri" pitchFamily="34" charset="-122"/>
+                <a:cs typeface="Calibri" pitchFamily="34" charset="-120"/>
+              </a:rPr>
+              <a:t>nomic-embed-text · 768-d</a:t>
+            </a:r>
+            <a:endParaRPr lang="en-US" sz="750" dirty="0"/>
+          </a:p>
+        </p:txBody>
+      </p:sp>
+      <p:sp>
+        <p:nvSpPr>
+          <p:cNvPr id="83" name="Shape 68"/>
+          <p:cNvSpPr/>
+          <p:nvPr/>
+        </p:nvSpPr>
+        <p:spPr>
+          <a:xfrm>
+            <a:off x="10012680" y="4663440"/>
+            <a:ext cx="1554480" cy="530352"/>
+          </a:xfrm>
+          <a:prstGeom prst="roundRect">
+            <a:avLst>
+              <a:gd name="adj" fmla="val 12069"/>
+            </a:avLst>
+          </a:prstGeom>
+          <a:solidFill>
+            <a:srgbClr val="FFFFFF"/>
+          </a:solidFill>
+          <a:ln w="12700">
+            <a:solidFill>
+              <a:srgbClr val="E0E5EA"/>
+            </a:solidFill>
+            <a:prstDash val="solid"/>
+          </a:ln>
+          <a:effectLst>
+            <a:outerShdw sx="100000" sy="100000" kx="0" ky="0" algn="bl" rotWithShape="0" blurRad="76200" dist="25400" dir="5400000">
+              <a:srgbClr val="1A2027">
+                <a:alpha val="10000"/>
+              </a:srgbClr>
+            </a:outerShdw>
+          </a:effectLst>
+        </p:spPr>
+      </p:sp>
+      <p:sp>
+        <p:nvSpPr>
+          <p:cNvPr id="84" name="Shape 69"/>
+          <p:cNvSpPr/>
+          <p:nvPr/>
+        </p:nvSpPr>
+        <p:spPr>
+          <a:xfrm>
+            <a:off x="10122408" y="4736592"/>
+            <a:ext cx="256032" cy="256032"/>
+          </a:xfrm>
+          <a:prstGeom prst="ellipse">
+            <a:avLst/>
+          </a:prstGeom>
+          <a:solidFill>
+            <a:srgbClr val="2FA36B"/>
+          </a:solidFill>
+          <a:ln/>
+          <a:effectLst>
+            <a:outerShdw sx="100000" sy="100000" kx="0" ky="0" algn="bl" rotWithShape="0" blurRad="127000" dist="38100" dir="5400000">
+              <a:srgbClr val="1A2027">
+                <a:alpha val="22000"/>
+              </a:srgbClr>
+            </a:outerShdw>
+          </a:effectLst>
+        </p:spPr>
+      </p:sp>
+      <p:pic>
+        <p:nvPicPr>
+          <p:cNvPr id="85" name="Image 13" descr="preencoded.png">    </p:cNvPr>
+          <p:cNvPicPr>
+            <a:picLocks noChangeAspect="1"/>
+          </p:cNvPicPr>
+          <p:nvPr/>
+        </p:nvPicPr>
+        <p:blipFill>
+          <a:blip r:embed="rId14"/>
+          <a:stretch>
+            <a:fillRect/>
+          </a:stretch>
+        </p:blipFill>
+        <p:spPr>
+          <a:xfrm>
+            <a:off x="10183856" y="4798040"/>
+            <a:ext cx="133137" cy="133137"/>
+          </a:xfrm>
+          <a:prstGeom prst="rect">
+            <a:avLst/>
+          </a:prstGeom>
+        </p:spPr>
+      </p:pic>
+      <p:sp>
+        <p:nvSpPr>
+          <p:cNvPr id="86" name="Text 70"/>
+          <p:cNvSpPr/>
+          <p:nvPr/>
+        </p:nvSpPr>
+        <p:spPr>
+          <a:xfrm>
+            <a:off x="10469880" y="4700016"/>
+            <a:ext cx="1005840" cy="274320"/>
+          </a:xfrm>
+          <a:prstGeom prst="rect">
+            <a:avLst/>
+          </a:prstGeom>
+          <a:noFill/>
+          <a:ln/>
+        </p:spPr>
+        <p:txBody>
+          <a:bodyPr wrap="square" lIns="0" tIns="0" rIns="0" bIns="0" rtlCol="0" anchor="ctr"/>
+          <a:lstStyle/>
+          <a:p>
+            <a:pPr indent="0" marL="0">
+              <a:buNone/>
+            </a:pPr>
+            <a:r>
+              <a:rPr lang="en-US" sz="950" b="1" dirty="0">
+                <a:solidFill>
+                  <a:srgbClr val="212933"/>
+                </a:solidFill>
+                <a:latin typeface="Calibri" pitchFamily="34" charset="0"/>
+                <a:ea typeface="Calibri" pitchFamily="34" charset="-122"/>
+                <a:cs typeface="Calibri" pitchFamily="34" charset="-120"/>
+              </a:rPr>
+              <a:t>Qdrant vector DB</a:t>
+            </a:r>
+            <a:endParaRPr lang="en-US" sz="950" dirty="0"/>
+          </a:p>
+        </p:txBody>
+      </p:sp>
+      <p:sp>
+        <p:nvSpPr>
+          <p:cNvPr id="87" name="Text 71"/>
+          <p:cNvSpPr/>
+          <p:nvPr/>
+        </p:nvSpPr>
+        <p:spPr>
+          <a:xfrm>
+            <a:off x="10140696" y="4974336"/>
+            <a:ext cx="1316736" cy="201168"/>
+          </a:xfrm>
+          <a:prstGeom prst="rect">
+            <a:avLst/>
+          </a:prstGeom>
+          <a:noFill/>
+          <a:ln/>
+        </p:spPr>
+        <p:txBody>
+          <a:bodyPr wrap="square" lIns="0" tIns="0" rIns="0" bIns="0" rtlCol="0" anchor="ctr"/>
+          <a:lstStyle/>
+          <a:p>
+            <a:pPr indent="0" marL="0">
+              <a:lnSpc>
+                <a:spcPct val="98000"/>
+              </a:lnSpc>
+              <a:buNone/>
+            </a:pPr>
+            <a:r>
+              <a:rPr lang="en-US" sz="750" dirty="0">
+                <a:solidFill>
+                  <a:srgbClr val="5C6B7A"/>
+                </a:solidFill>
+                <a:latin typeface="Calibri" pitchFamily="34" charset="0"/>
+                <a:ea typeface="Calibri" pitchFamily="34" charset="-122"/>
+                <a:cs typeface="Calibri" pitchFamily="34" charset="-120"/>
+              </a:rPr>
+              <a:t>Docker · 5 collections · hybrid</a:t>
+            </a:r>
+            <a:endParaRPr lang="en-US" sz="750" dirty="0"/>
+          </a:p>
+        </p:txBody>
+      </p:sp>
+      <p:sp>
+        <p:nvSpPr>
+          <p:cNvPr id="88" name="Shape 72"/>
+          <p:cNvSpPr/>
+          <p:nvPr/>
+        </p:nvSpPr>
+        <p:spPr>
+          <a:xfrm>
+            <a:off x="10012680" y="5285232"/>
+            <a:ext cx="1554480" cy="530352"/>
+          </a:xfrm>
+          <a:prstGeom prst="roundRect">
+            <a:avLst>
+              <a:gd name="adj" fmla="val 12069"/>
+            </a:avLst>
+          </a:prstGeom>
+          <a:solidFill>
+            <a:srgbClr val="FFFFFF"/>
+          </a:solidFill>
+          <a:ln w="12700">
+            <a:solidFill>
+              <a:srgbClr val="E0E5EA"/>
+            </a:solidFill>
+            <a:prstDash val="solid"/>
+          </a:ln>
+          <a:effectLst>
+            <a:outerShdw sx="100000" sy="100000" kx="0" ky="0" algn="bl" rotWithShape="0" blurRad="76200" dist="25400" dir="5400000">
+              <a:srgbClr val="1A2027">
+                <a:alpha val="10000"/>
+              </a:srgbClr>
+            </a:outerShdw>
+          </a:effectLst>
+        </p:spPr>
+      </p:sp>
+      <p:sp>
+        <p:nvSpPr>
+          <p:cNvPr id="89" name="Shape 73"/>
+          <p:cNvSpPr/>
+          <p:nvPr/>
+        </p:nvSpPr>
+        <p:spPr>
+          <a:xfrm>
+            <a:off x="10122408" y="5358384"/>
+            <a:ext cx="256032" cy="256032"/>
+          </a:xfrm>
+          <a:prstGeom prst="ellipse">
+            <a:avLst/>
+          </a:prstGeom>
+          <a:solidFill>
+            <a:srgbClr val="2FA36B"/>
+          </a:solidFill>
+          <a:ln/>
+          <a:effectLst>
+            <a:outerShdw sx="100000" sy="100000" kx="0" ky="0" algn="bl" rotWithShape="0" blurRad="127000" dist="38100" dir="5400000">
+              <a:srgbClr val="1A2027">
+                <a:alpha val="22000"/>
+              </a:srgbClr>
+            </a:outerShdw>
+          </a:effectLst>
+        </p:spPr>
+      </p:sp>
+      <p:pic>
+        <p:nvPicPr>
+          <p:cNvPr id="90" name="Image 14" descr="preencoded.png">    </p:cNvPr>
+          <p:cNvPicPr>
+            <a:picLocks noChangeAspect="1"/>
+          </p:cNvPicPr>
+          <p:nvPr/>
+        </p:nvPicPr>
+        <p:blipFill>
+          <a:blip r:embed="rId15"/>
+          <a:stretch>
+            <a:fillRect/>
+          </a:stretch>
+        </p:blipFill>
+        <p:spPr>
+          <a:xfrm>
+            <a:off x="10183856" y="5419832"/>
+            <a:ext cx="133137" cy="133137"/>
+          </a:xfrm>
+          <a:prstGeom prst="rect">
+            <a:avLst/>
+          </a:prstGeom>
+        </p:spPr>
+      </p:pic>
+      <p:sp>
+        <p:nvSpPr>
+          <p:cNvPr id="91" name="Text 74"/>
+          <p:cNvSpPr/>
+          <p:nvPr/>
+        </p:nvSpPr>
+        <p:spPr>
+          <a:xfrm>
+            <a:off x="10469880" y="5321808"/>
+            <a:ext cx="1005840" cy="274320"/>
+          </a:xfrm>
+          <a:prstGeom prst="rect">
+            <a:avLst/>
+          </a:prstGeom>
+          <a:noFill/>
+          <a:ln/>
+        </p:spPr>
+        <p:txBody>
+          <a:bodyPr wrap="square" lIns="0" tIns="0" rIns="0" bIns="0" rtlCol="0" anchor="ctr"/>
+          <a:lstStyle/>
+          <a:p>
+            <a:pPr indent="0" marL="0">
+              <a:buNone/>
+            </a:pPr>
+            <a:r>
+              <a:rPr lang="en-US" sz="950" b="1" dirty="0">
+                <a:solidFill>
+                  <a:srgbClr val="212933"/>
+                </a:solidFill>
+                <a:latin typeface="Calibri" pitchFamily="34" charset="0"/>
+                <a:ea typeface="Calibri" pitchFamily="34" charset="-122"/>
+                <a:cs typeface="Calibri" pitchFamily="34" charset="-120"/>
+              </a:rPr>
+              <a:t>MongoDB</a:t>
+            </a:r>
+            <a:endParaRPr lang="en-US" sz="950" dirty="0"/>
+          </a:p>
+        </p:txBody>
+      </p:sp>
+      <p:sp>
+        <p:nvSpPr>
+          <p:cNvPr id="92" name="Text 75"/>
+          <p:cNvSpPr/>
+          <p:nvPr/>
+        </p:nvSpPr>
+        <p:spPr>
+          <a:xfrm>
+            <a:off x="10140696" y="5596128"/>
+            <a:ext cx="1316736" cy="201168"/>
+          </a:xfrm>
+          <a:prstGeom prst="rect">
+            <a:avLst/>
+          </a:prstGeom>
+          <a:noFill/>
+          <a:ln/>
+        </p:spPr>
+        <p:txBody>
+          <a:bodyPr wrap="square" lIns="0" tIns="0" rIns="0" bIns="0" rtlCol="0" anchor="ctr"/>
+          <a:lstStyle/>
+          <a:p>
+            <a:pPr indent="0" marL="0">
+              <a:lnSpc>
+                <a:spcPct val="98000"/>
+              </a:lnSpc>
+              <a:buNone/>
+            </a:pPr>
+            <a:r>
+              <a:rPr lang="en-US" sz="750" dirty="0">
+                <a:solidFill>
+                  <a:srgbClr val="5C6B7A"/>
+                </a:solidFill>
+                <a:latin typeface="Calibri" pitchFamily="34" charset="0"/>
+                <a:ea typeface="Calibri" pitchFamily="34" charset="-122"/>
+                <a:cs typeface="Calibri" pitchFamily="34" charset="-120"/>
+              </a:rPr>
+              <a:t>Docker · app + reference DBs</a:t>
+            </a:r>
+            <a:endParaRPr lang="en-US" sz="750" dirty="0"/>
+          </a:p>
+        </p:txBody>
+      </p:sp>
+      <p:sp>
+        <p:nvSpPr>
+          <p:cNvPr id="93" name="Shape 76"/>
+          <p:cNvSpPr/>
+          <p:nvPr/>
+        </p:nvSpPr>
+        <p:spPr>
+          <a:xfrm>
+            <a:off x="2670048" y="2331720"/>
+            <a:ext cx="694944" cy="0"/>
+          </a:xfrm>
+          <a:prstGeom prst="line">
+            <a:avLst/>
+          </a:prstGeom>
+          <a:noFill/>
+          <a:ln w="19050">
+            <a:solidFill>
+              <a:srgbClr val="8A9AA8"/>
+            </a:solidFill>
+            <a:prstDash val="solid"/>
+            <a:tailEnd type="triangle"/>
+          </a:ln>
+        </p:spPr>
+      </p:sp>
+      <p:sp>
+        <p:nvSpPr>
+          <p:cNvPr id="94" name="Text 77"/>
+          <p:cNvSpPr/>
+          <p:nvPr/>
+        </p:nvSpPr>
+        <p:spPr>
+          <a:xfrm>
+            <a:off x="2560320" y="2084832"/>
+            <a:ext cx="914400" cy="219456"/>
+          </a:xfrm>
+          <a:prstGeom prst="rect">
+            <a:avLst/>
+          </a:prstGeom>
+          <a:noFill/>
+          <a:ln/>
+        </p:spPr>
+        <p:txBody>
+          <a:bodyPr wrap="square" lIns="0" tIns="0" rIns="0" bIns="0" rtlCol="0" anchor="ctr"/>
+          <a:lstStyle/>
+          <a:p>
+            <a:pPr algn="ctr" indent="0" marL="0">
+              <a:buNone/>
+            </a:pPr>
+            <a:r>
+              <a:rPr lang="en-US" sz="750" b="1" dirty="0">
+                <a:solidFill>
+                  <a:srgbClr val="5C6B7A"/>
+                </a:solidFill>
+                <a:latin typeface="Calibri" pitchFamily="34" charset="0"/>
+                <a:ea typeface="Calibri" pitchFamily="34" charset="-122"/>
+                <a:cs typeface="Calibri" pitchFamily="34" charset="-120"/>
+              </a:rPr>
+              <a:t>HTTPS · SSE</a:t>
+            </a:r>
+            <a:endParaRPr lang="en-US" sz="750" dirty="0"/>
+          </a:p>
+        </p:txBody>
+      </p:sp>
+      <p:sp>
+        <p:nvSpPr>
+          <p:cNvPr id="95" name="Shape 78"/>
+          <p:cNvSpPr/>
+          <p:nvPr/>
+        </p:nvSpPr>
+        <p:spPr>
+          <a:xfrm flipV="1">
+            <a:off x="2670048" y="2926080"/>
+            <a:ext cx="694944" cy="365760"/>
+          </a:xfrm>
+          <a:prstGeom prst="line">
+            <a:avLst/>
+          </a:prstGeom>
+          <a:noFill/>
+          <a:ln w="19050">
+            <a:solidFill>
+              <a:srgbClr val="8A9AA8"/>
+            </a:solidFill>
+            <a:prstDash val="solid"/>
+            <a:tailEnd type="triangle"/>
+          </a:ln>
+        </p:spPr>
+      </p:sp>
+      <p:sp>
+        <p:nvSpPr>
+          <p:cNvPr id="96" name="Shape 79"/>
+          <p:cNvSpPr/>
+          <p:nvPr/>
+        </p:nvSpPr>
+        <p:spPr>
+          <a:xfrm>
+            <a:off x="2670048" y="3611880"/>
+            <a:ext cx="694944" cy="365760"/>
+          </a:xfrm>
+          <a:prstGeom prst="line">
+            <a:avLst/>
+          </a:prstGeom>
+          <a:noFill/>
+          <a:ln w="19050">
+            <a:solidFill>
+              <a:srgbClr val="8A9AA8"/>
+            </a:solidFill>
+            <a:prstDash val="solid"/>
+            <a:tailEnd type="triangle"/>
+          </a:ln>
+        </p:spPr>
+      </p:sp>
+      <p:sp>
+        <p:nvSpPr>
+          <p:cNvPr id="97" name="Text 80"/>
+          <p:cNvSpPr/>
+          <p:nvPr/>
+        </p:nvSpPr>
+        <p:spPr>
+          <a:xfrm>
+            <a:off x="2487168" y="3913632"/>
+            <a:ext cx="914400" cy="219456"/>
+          </a:xfrm>
+          <a:prstGeom prst="rect">
+            <a:avLst/>
+          </a:prstGeom>
+          <a:noFill/>
+          <a:ln/>
+        </p:spPr>
+        <p:txBody>
+          <a:bodyPr wrap="square" lIns="0" tIns="0" rIns="0" bIns="0" rtlCol="0" anchor="ctr"/>
+          <a:lstStyle/>
+          <a:p>
+            <a:pPr algn="ctr" indent="0" marL="0">
+              <a:buNone/>
+            </a:pPr>
+            <a:r>
+              <a:rPr lang="en-US" sz="750" b="1" dirty="0">
+                <a:solidFill>
+                  <a:srgbClr val="5C6B7A"/>
+                </a:solidFill>
+                <a:latin typeface="Calibri" pitchFamily="34" charset="0"/>
+                <a:ea typeface="Calibri" pitchFamily="34" charset="-122"/>
+                <a:cs typeface="Calibri" pitchFamily="34" charset="-120"/>
+              </a:rPr>
+              <a:t>WebRTC audio</a:t>
+            </a:r>
+            <a:endParaRPr lang="en-US" sz="750" dirty="0"/>
+          </a:p>
+        </p:txBody>
+      </p:sp>
+      <p:sp>
+        <p:nvSpPr>
+          <p:cNvPr id="98" name="Shape 81"/>
+          <p:cNvSpPr/>
+          <p:nvPr/>
+        </p:nvSpPr>
+        <p:spPr>
+          <a:xfrm>
+            <a:off x="2670048" y="4498848"/>
+            <a:ext cx="694944" cy="0"/>
+          </a:xfrm>
+          <a:prstGeom prst="line">
+            <a:avLst/>
+          </a:prstGeom>
+          <a:noFill/>
+          <a:ln w="19050">
+            <a:solidFill>
+              <a:srgbClr val="8A9AA8"/>
+            </a:solidFill>
+            <a:prstDash val="solid"/>
+            <a:tailEnd type="triangle"/>
+          </a:ln>
+        </p:spPr>
+      </p:sp>
+      <p:sp>
+        <p:nvSpPr>
+          <p:cNvPr id="99" name="Text 82"/>
+          <p:cNvSpPr/>
+          <p:nvPr/>
+        </p:nvSpPr>
+        <p:spPr>
+          <a:xfrm>
+            <a:off x="2615184" y="4261104"/>
+            <a:ext cx="822960" cy="219456"/>
+          </a:xfrm>
+          <a:prstGeom prst="rect">
+            <a:avLst/>
+          </a:prstGeom>
+          <a:noFill/>
+          <a:ln/>
+        </p:spPr>
+        <p:txBody>
+          <a:bodyPr wrap="square" lIns="0" tIns="0" rIns="0" bIns="0" rtlCol="0" anchor="ctr"/>
+          <a:lstStyle/>
+          <a:p>
+            <a:pPr algn="ctr" indent="0" marL="0">
+              <a:buNone/>
+            </a:pPr>
+            <a:r>
+              <a:rPr lang="en-US" sz="750" b="1" dirty="0">
+                <a:solidFill>
+                  <a:srgbClr val="5C6B7A"/>
+                </a:solidFill>
+                <a:latin typeface="Calibri" pitchFamily="34" charset="0"/>
+                <a:ea typeface="Calibri" pitchFamily="34" charset="-122"/>
+                <a:cs typeface="Calibri" pitchFamily="34" charset="-120"/>
+              </a:rPr>
+              <a:t>PSTN</a:t>
+            </a:r>
+            <a:endParaRPr lang="en-US" sz="750" dirty="0"/>
+          </a:p>
+        </p:txBody>
+      </p:sp>
+      <p:sp>
+        <p:nvSpPr>
+          <p:cNvPr id="100" name="Shape 83"/>
+          <p:cNvSpPr/>
+          <p:nvPr/>
+        </p:nvSpPr>
+        <p:spPr>
+          <a:xfrm>
+            <a:off x="4407408" y="3154680"/>
+            <a:ext cx="0" cy="411480"/>
+          </a:xfrm>
+          <a:prstGeom prst="line">
+            <a:avLst/>
+          </a:prstGeom>
+          <a:noFill/>
+          <a:ln w="19050">
+            <a:solidFill>
+              <a:srgbClr val="8A9AA8"/>
+            </a:solidFill>
+            <a:prstDash val="solid"/>
+            <a:headEnd type="triangle"/>
+            <a:tailEnd type="none"/>
+          </a:ln>
+        </p:spPr>
+      </p:sp>
+      <p:sp>
+        <p:nvSpPr>
+          <p:cNvPr id="101" name="Text 84"/>
+          <p:cNvSpPr/>
+          <p:nvPr/>
+        </p:nvSpPr>
+        <p:spPr>
+          <a:xfrm>
+            <a:off x="4480560" y="3218688"/>
+            <a:ext cx="1051560" cy="219456"/>
+          </a:xfrm>
+          <a:prstGeom prst="rect">
+            <a:avLst/>
+          </a:prstGeom>
+          <a:noFill/>
+          <a:ln/>
+        </p:spPr>
+        <p:txBody>
+          <a:bodyPr wrap="square" lIns="0" tIns="0" rIns="0" bIns="0" rtlCol="0" anchor="ctr"/>
+          <a:lstStyle/>
+          <a:p>
+            <a:pPr algn="ctr" indent="0" marL="0">
+              <a:buNone/>
+            </a:pPr>
+            <a:r>
+              <a:rPr lang="en-US" sz="750" b="1" dirty="0">
+                <a:solidFill>
+                  <a:srgbClr val="5C6B7A"/>
+                </a:solidFill>
+                <a:latin typeface="Calibri" pitchFamily="34" charset="0"/>
+                <a:ea typeface="Calibri" pitchFamily="34" charset="-122"/>
+                <a:cs typeface="Calibri" pitchFamily="34" charset="-120"/>
+              </a:rPr>
+              <a:t>webhooks · media WS</a:t>
+            </a:r>
+            <a:endParaRPr lang="en-US" sz="750" dirty="0"/>
+          </a:p>
+        </p:txBody>
+      </p:sp>
+      <p:sp>
+        <p:nvSpPr>
+          <p:cNvPr id="102" name="Shape 85"/>
+          <p:cNvSpPr/>
+          <p:nvPr/>
+        </p:nvSpPr>
+        <p:spPr>
+          <a:xfrm flipV="1">
+            <a:off x="5458968" y="2240280"/>
+            <a:ext cx="694944" cy="228600"/>
+          </a:xfrm>
+          <a:prstGeom prst="line">
+            <a:avLst/>
+          </a:prstGeom>
+          <a:noFill/>
+          <a:ln w="19050">
+            <a:solidFill>
+              <a:srgbClr val="8A9AA8"/>
+            </a:solidFill>
+            <a:prstDash val="solid"/>
+            <a:tailEnd type="triangle"/>
+          </a:ln>
+        </p:spPr>
+      </p:sp>
+      <p:sp>
+        <p:nvSpPr>
+          <p:cNvPr id="103" name="Text 86"/>
+          <p:cNvSpPr/>
+          <p:nvPr/>
+        </p:nvSpPr>
+        <p:spPr>
+          <a:xfrm>
+            <a:off x="5394960" y="1956816"/>
+            <a:ext cx="868680" cy="219456"/>
+          </a:xfrm>
+          <a:prstGeom prst="rect">
+            <a:avLst/>
+          </a:prstGeom>
+          <a:noFill/>
+          <a:ln/>
+        </p:spPr>
+        <p:txBody>
+          <a:bodyPr wrap="square" lIns="0" tIns="0" rIns="0" bIns="0" rtlCol="0" anchor="ctr"/>
+          <a:lstStyle/>
+          <a:p>
+            <a:pPr algn="ctr" indent="0" marL="0">
+              <a:buNone/>
+            </a:pPr>
+            <a:r>
+              <a:rPr lang="en-US" sz="750" b="1" dirty="0">
+                <a:solidFill>
+                  <a:srgbClr val="5C6B7A"/>
+                </a:solidFill>
+                <a:latin typeface="Calibri" pitchFamily="34" charset="0"/>
+                <a:ea typeface="Calibri" pitchFamily="34" charset="-122"/>
+                <a:cs typeface="Calibri" pitchFamily="34" charset="-120"/>
+              </a:rPr>
+              <a:t>tunnel</a:t>
+            </a:r>
+            <a:endParaRPr lang="en-US" sz="750" dirty="0"/>
+          </a:p>
+        </p:txBody>
+      </p:sp>
+      <p:sp>
+        <p:nvSpPr>
+          <p:cNvPr id="104" name="Shape 87"/>
+          <p:cNvSpPr/>
+          <p:nvPr/>
+        </p:nvSpPr>
+        <p:spPr>
+          <a:xfrm flipV="1">
+            <a:off x="9299448" y="2331720"/>
+            <a:ext cx="685800" cy="1143000"/>
+          </a:xfrm>
+          <a:prstGeom prst="line">
+            <a:avLst/>
+          </a:prstGeom>
+          <a:noFill/>
+          <a:ln w="19050">
+            <a:solidFill>
+              <a:srgbClr val="8A9AA8"/>
+            </a:solidFill>
+            <a:prstDash val="solid"/>
+            <a:tailEnd type="triangle"/>
+          </a:ln>
+        </p:spPr>
+      </p:sp>
+      <p:sp>
+        <p:nvSpPr>
+          <p:cNvPr id="105" name="Text 88"/>
+          <p:cNvSpPr/>
+          <p:nvPr/>
+        </p:nvSpPr>
+        <p:spPr>
+          <a:xfrm>
+            <a:off x="9235440" y="2724912"/>
+            <a:ext cx="777240" cy="219456"/>
+          </a:xfrm>
+          <a:prstGeom prst="rect">
+            <a:avLst/>
+          </a:prstGeom>
+          <a:noFill/>
+          <a:ln/>
+        </p:spPr>
+        <p:txBody>
+          <a:bodyPr wrap="square" lIns="0" tIns="0" rIns="0" bIns="0" rtlCol="0" anchor="ctr"/>
+          <a:lstStyle/>
+          <a:p>
+            <a:pPr algn="ctr" indent="0" marL="0">
+              <a:buNone/>
+            </a:pPr>
+            <a:r>
+              <a:rPr lang="en-US" sz="750" b="1" dirty="0">
+                <a:solidFill>
+                  <a:srgbClr val="5C6B7A"/>
+                </a:solidFill>
+                <a:latin typeface="Calibri" pitchFamily="34" charset="0"/>
+                <a:ea typeface="Calibri" pitchFamily="34" charset="-122"/>
+                <a:cs typeface="Calibri" pitchFamily="34" charset="-120"/>
+              </a:rPr>
+              <a:t>WSS audio</a:t>
+            </a:r>
+            <a:endParaRPr lang="en-US" sz="750" dirty="0"/>
+          </a:p>
+        </p:txBody>
+      </p:sp>
+      <p:sp>
+        <p:nvSpPr>
+          <p:cNvPr id="106" name="Shape 89"/>
+          <p:cNvSpPr/>
+          <p:nvPr/>
+        </p:nvSpPr>
+        <p:spPr>
+          <a:xfrm flipV="1">
+            <a:off x="9299448" y="3127248"/>
+            <a:ext cx="685800" cy="1124712"/>
+          </a:xfrm>
+          <a:prstGeom prst="line">
+            <a:avLst/>
+          </a:prstGeom>
+          <a:noFill/>
+          <a:ln w="19050">
+            <a:solidFill>
+              <a:srgbClr val="8A9AA8"/>
+            </a:solidFill>
+            <a:prstDash val="solid"/>
+            <a:tailEnd type="triangle"/>
+          </a:ln>
+        </p:spPr>
+      </p:sp>
+      <p:sp>
+        <p:nvSpPr>
+          <p:cNvPr id="107" name="Text 90"/>
+          <p:cNvSpPr/>
+          <p:nvPr/>
+        </p:nvSpPr>
+        <p:spPr>
+          <a:xfrm>
+            <a:off x="9217152" y="3520440"/>
+            <a:ext cx="777240" cy="219456"/>
+          </a:xfrm>
+          <a:prstGeom prst="rect">
+            <a:avLst/>
+          </a:prstGeom>
+          <a:noFill/>
+          <a:ln/>
+        </p:spPr>
+        <p:txBody>
+          <a:bodyPr wrap="square" lIns="0" tIns="0" rIns="0" bIns="0" rtlCol="0" anchor="ctr"/>
+          <a:lstStyle/>
+          <a:p>
+            <a:pPr algn="ctr" indent="0" marL="0">
+              <a:buNone/>
+            </a:pPr>
+            <a:r>
+              <a:rPr lang="en-US" sz="750" b="1" dirty="0">
+                <a:solidFill>
+                  <a:srgbClr val="5C6B7A"/>
+                </a:solidFill>
+                <a:latin typeface="Calibri" pitchFamily="34" charset="0"/>
+                <a:ea typeface="Calibri" pitchFamily="34" charset="-122"/>
+                <a:cs typeface="Calibri" pitchFamily="34" charset="-120"/>
+              </a:rPr>
+              <a:t>LLM calls</a:t>
+            </a:r>
+            <a:endParaRPr lang="en-US" sz="750" dirty="0"/>
+          </a:p>
+        </p:txBody>
+      </p:sp>
+      <p:sp>
+        <p:nvSpPr>
+          <p:cNvPr id="108" name="Shape 91"/>
+          <p:cNvSpPr/>
+          <p:nvPr/>
+        </p:nvSpPr>
+        <p:spPr>
+          <a:xfrm flipV="1">
+            <a:off x="9299448" y="4306824"/>
+            <a:ext cx="685800" cy="128016"/>
+          </a:xfrm>
+          <a:prstGeom prst="line">
+            <a:avLst/>
+          </a:prstGeom>
+          <a:noFill/>
+          <a:ln w="19050">
+            <a:solidFill>
+              <a:srgbClr val="8A9AA8"/>
+            </a:solidFill>
+            <a:prstDash val="solid"/>
+            <a:tailEnd type="triangle"/>
+          </a:ln>
+        </p:spPr>
+      </p:sp>
+      <p:sp>
+        <p:nvSpPr>
+          <p:cNvPr id="109" name="Text 92"/>
+          <p:cNvSpPr/>
+          <p:nvPr/>
+        </p:nvSpPr>
+        <p:spPr>
+          <a:xfrm>
+            <a:off x="9454896" y="4059936"/>
+            <a:ext cx="548640" cy="219456"/>
+          </a:xfrm>
+          <a:prstGeom prst="rect">
+            <a:avLst/>
+          </a:prstGeom>
+          <a:noFill/>
+          <a:ln/>
+        </p:spPr>
+        <p:txBody>
+          <a:bodyPr wrap="square" lIns="0" tIns="0" rIns="0" bIns="0" rtlCol="0" anchor="ctr"/>
+          <a:lstStyle/>
+          <a:p>
+            <a:pPr algn="ctr" indent="0" marL="0">
+              <a:buNone/>
+            </a:pPr>
+            <a:r>
+              <a:rPr lang="en-US" sz="750" b="1" dirty="0">
+                <a:solidFill>
+                  <a:srgbClr val="5C6B7A"/>
+                </a:solidFill>
+                <a:latin typeface="Calibri" pitchFamily="34" charset="0"/>
+                <a:ea typeface="Calibri" pitchFamily="34" charset="-122"/>
+                <a:cs typeface="Calibri" pitchFamily="34" charset="-120"/>
+              </a:rPr>
+              <a:t>embed</a:t>
+            </a:r>
+            <a:endParaRPr lang="en-US" sz="750" dirty="0"/>
+          </a:p>
+        </p:txBody>
+      </p:sp>
+      <p:sp>
+        <p:nvSpPr>
+          <p:cNvPr id="110" name="Shape 93"/>
+          <p:cNvSpPr/>
+          <p:nvPr/>
+        </p:nvSpPr>
+        <p:spPr>
+          <a:xfrm>
+            <a:off x="9299448" y="4645152"/>
+            <a:ext cx="685800" cy="283464"/>
+          </a:xfrm>
+          <a:prstGeom prst="line">
+            <a:avLst/>
+          </a:prstGeom>
+          <a:noFill/>
+          <a:ln w="19050">
+            <a:solidFill>
+              <a:srgbClr val="8A9AA8"/>
+            </a:solidFill>
+            <a:prstDash val="solid"/>
+            <a:tailEnd type="triangle"/>
+          </a:ln>
+        </p:spPr>
+      </p:sp>
+      <p:sp>
+        <p:nvSpPr>
+          <p:cNvPr id="111" name="Text 94"/>
+          <p:cNvSpPr/>
+          <p:nvPr/>
+        </p:nvSpPr>
+        <p:spPr>
+          <a:xfrm>
+            <a:off x="9345168" y="4901184"/>
+            <a:ext cx="594360" cy="219456"/>
+          </a:xfrm>
+          <a:prstGeom prst="rect">
+            <a:avLst/>
+          </a:prstGeom>
+          <a:noFill/>
+          <a:ln/>
+        </p:spPr>
+        <p:txBody>
+          <a:bodyPr wrap="square" lIns="0" tIns="0" rIns="0" bIns="0" rtlCol="0" anchor="ctr"/>
+          <a:lstStyle/>
+          <a:p>
+            <a:pPr algn="ctr" indent="0" marL="0">
+              <a:buNone/>
+            </a:pPr>
+            <a:r>
+              <a:rPr lang="en-US" sz="750" b="1" dirty="0">
+                <a:solidFill>
+                  <a:srgbClr val="5C6B7A"/>
+                </a:solidFill>
+                <a:latin typeface="Calibri" pitchFamily="34" charset="0"/>
+                <a:ea typeface="Calibri" pitchFamily="34" charset="-122"/>
+                <a:cs typeface="Calibri" pitchFamily="34" charset="-120"/>
+              </a:rPr>
+              <a:t>RAG</a:t>
+            </a:r>
+            <a:endParaRPr lang="en-US" sz="750" dirty="0"/>
+          </a:p>
+        </p:txBody>
+      </p:sp>
+      <p:sp>
+        <p:nvSpPr>
+          <p:cNvPr id="112" name="Shape 95"/>
+          <p:cNvSpPr/>
+          <p:nvPr/>
+        </p:nvSpPr>
+        <p:spPr>
+          <a:xfrm>
+            <a:off x="9299448" y="5413248"/>
+            <a:ext cx="685800" cy="137160"/>
+          </a:xfrm>
+          <a:prstGeom prst="line">
+            <a:avLst/>
+          </a:prstGeom>
+          <a:noFill/>
+          <a:ln w="19050">
+            <a:solidFill>
+              <a:srgbClr val="8A9AA8"/>
+            </a:solidFill>
+            <a:prstDash val="solid"/>
+            <a:tailEnd type="triangle"/>
+          </a:ln>
+        </p:spPr>
+      </p:sp>
+      <p:sp>
+        <p:nvSpPr>
+          <p:cNvPr id="113" name="Text 96"/>
+          <p:cNvSpPr/>
+          <p:nvPr/>
+        </p:nvSpPr>
+        <p:spPr>
+          <a:xfrm>
+            <a:off x="9272016" y="5157216"/>
+            <a:ext cx="731520" cy="219456"/>
+          </a:xfrm>
+          <a:prstGeom prst="rect">
+            <a:avLst/>
+          </a:prstGeom>
+          <a:noFill/>
+          <a:ln/>
+        </p:spPr>
+        <p:txBody>
+          <a:bodyPr wrap="square" lIns="0" tIns="0" rIns="0" bIns="0" rtlCol="0" anchor="ctr"/>
+          <a:lstStyle/>
+          <a:p>
+            <a:pPr algn="ctr" indent="0" marL="0">
+              <a:buNone/>
+            </a:pPr>
+            <a:r>
+              <a:rPr lang="en-US" sz="750" b="1" dirty="0">
+                <a:solidFill>
+                  <a:srgbClr val="5C6B7A"/>
+                </a:solidFill>
+                <a:latin typeface="Calibri" pitchFamily="34" charset="0"/>
+                <a:ea typeface="Calibri" pitchFamily="34" charset="-122"/>
+                <a:cs typeface="Calibri" pitchFamily="34" charset="-120"/>
+              </a:rPr>
+              <a:t>persist</a:t>
+            </a:r>
+            <a:endParaRPr lang="en-US" sz="750" dirty="0"/>
+          </a:p>
+        </p:txBody>
+      </p:sp>
+      <p:sp>
+        <p:nvSpPr>
+          <p:cNvPr id="114" name="Shape 97"/>
+          <p:cNvSpPr/>
+          <p:nvPr/>
+        </p:nvSpPr>
+        <p:spPr>
+          <a:xfrm>
+            <a:off x="502920" y="6035040"/>
+            <a:ext cx="11201400" cy="502920"/>
+          </a:xfrm>
+          <a:prstGeom prst="roundRect">
+            <a:avLst>
+              <a:gd name="adj" fmla="val 14545"/>
+            </a:avLst>
+          </a:prstGeom>
+          <a:solidFill>
+            <a:srgbClr val="222B36"/>
+          </a:solidFill>
+          <a:ln/>
+        </p:spPr>
+      </p:sp>
+      <p:pic>
+        <p:nvPicPr>
+          <p:cNvPr id="115" name="Image 15" descr="preencoded.png">    </p:cNvPr>
+          <p:cNvPicPr>
+            <a:picLocks noChangeAspect="1"/>
+          </p:cNvPicPr>
+          <p:nvPr/>
+        </p:nvPicPr>
+        <p:blipFill>
+          <a:blip r:embed="rId16"/>
+          <a:stretch>
+            <a:fillRect/>
+          </a:stretch>
+        </p:blipFill>
+        <p:spPr>
+          <a:xfrm>
+            <a:off x="777240" y="6153912"/>
+            <a:ext cx="274320" cy="274320"/>
+          </a:xfrm>
+          <a:prstGeom prst="rect">
+            <a:avLst/>
+          </a:prstGeom>
+        </p:spPr>
+      </p:pic>
+      <p:sp>
+        <p:nvSpPr>
+          <p:cNvPr id="116" name="Text 98"/>
+          <p:cNvSpPr/>
+          <p:nvPr/>
+        </p:nvSpPr>
+        <p:spPr>
+          <a:xfrm>
+            <a:off x="1188720" y="6035040"/>
+            <a:ext cx="10378440" cy="502920"/>
+          </a:xfrm>
+          <a:prstGeom prst="rect">
+            <a:avLst/>
+          </a:prstGeom>
+          <a:noFill/>
+          <a:ln/>
+        </p:spPr>
+        <p:txBody>
+          <a:bodyPr wrap="square" lIns="0" tIns="0" rIns="0" bIns="0" rtlCol="0" anchor="ctr"/>
+          <a:lstStyle/>
+          <a:p>
+            <a:pPr indent="0" marL="0">
+              <a:buNone/>
+            </a:pPr>
+            <a:r>
+              <a:rPr lang="en-US" sz="1050" dirty="0">
+                <a:solidFill>
+                  <a:srgbClr val="D7DEE7"/>
+                </a:solidFill>
+                <a:latin typeface="Calibri" pitchFamily="34" charset="0"/>
+                <a:ea typeface="Calibri" pitchFamily="34" charset="-122"/>
+                <a:cs typeface="Calibri" pitchFamily="34" charset="-120"/>
+              </a:rPr>
+              <a:t>Zero open inbound ports (outbound-only tunnel)  ·  TLS end-to-end  ·  signature-verified Twilio webhooks  ·  per-user rate limits  ·  daily token caps  ·  call-minute caps</a:t>
+            </a:r>
+            <a:endParaRPr lang="en-US" sz="1050" dirty="0"/>
+          </a:p>
+        </p:txBody>
+      </p:sp>
+    </p:spTree>
+  </p:cSld>
+  <p:clrMapOvr>
+    <a:masterClrMapping/>
+  </p:clrMapOvr>
+</p:sld>
+</file>
+
 <file path=ppt/slides/slide2.xml><?xml version="1.0" encoding="utf-8"?>
 <p:sld xmlns:a="http://schemas.openxmlformats.org/drawingml/2006/main" xmlns:r="http://schemas.openxmlformats.org/officeDocument/2006/relationships" xmlns:p="http://schemas.openxmlformats.org/presentationml/2006/main">
   <p:cSld name="Slide 2">
@@ -9694,7 +13553,7 @@
                 <a:ea typeface="Calibri" pitchFamily="34" charset="-122"/>
                 <a:cs typeface="Calibri" pitchFamily="34" charset="-120"/>
               </a:rPr>
-              <a:t>Claude (Haiku / Opus) via OpenRouter · Deepgram Nova-3</a:t>
+              <a:t>Claude (Haiku / Opus) via OpenRouter · Deepgram Nova-3 · Ollama embeddings</a:t>
             </a:r>
             <a:endParaRPr lang="en-US" sz="950" dirty="0"/>
           </a:p>
@@ -9775,7 +13634,7 @@
                 <a:ea typeface="Calibri" pitchFamily="34" charset="-122"/>
                 <a:cs typeface="Calibri" pitchFamily="34" charset="-120"/>
               </a:rPr>
-              <a:t>MongoDB 8 · swappable repo layer (Mongo / JSON / Databricks)</a:t>
+              <a:t>MongoDB 8 · Qdrant vector DB · repo layer (Mongo / JSON / Databricks)</a:t>
             </a:r>
             <a:endParaRPr lang="en-US" sz="950" dirty="0"/>
           </a:p>

</xml_diff>